<commit_message>
Some progress on L3
</commit_message>
<xml_diff>
--- a/images/figures.pptx
+++ b/images/figures.pptx
@@ -5,7 +5,7 @@
     <p:sldMasterId id="2147483648" r:id="rId1"/>
   </p:sldMasterIdLst>
   <p:notesMasterIdLst>
-    <p:notesMasterId r:id="rId7"/>
+    <p:notesMasterId r:id="rId8"/>
   </p:notesMasterIdLst>
   <p:sldIdLst>
     <p:sldId id="256" r:id="rId2"/>
@@ -13,6 +13,7 @@
     <p:sldId id="438" r:id="rId4"/>
     <p:sldId id="440" r:id="rId5"/>
     <p:sldId id="441" r:id="rId6"/>
+    <p:sldId id="442" r:id="rId7"/>
   </p:sldIdLst>
   <p:sldSz cx="12192000" cy="6858000"/>
   <p:notesSz cx="6858000" cy="9144000"/>
@@ -201,7 +202,7 @@
           <a:p>
             <a:fld id="{1E717189-69EA-4142-945D-85EE3E06463B}" type="datetimeFigureOut">
               <a:rPr lang="LID4096" smtClean="0"/>
-              <a:t>09/10/2025</a:t>
+              <a:t>09/15/2025</a:t>
             </a:fld>
             <a:endParaRPr lang="LID4096"/>
           </a:p>
@@ -1065,7 +1066,7 @@
           <a:p>
             <a:fld id="{6E06BE13-2967-499D-85E1-E8100B951B63}" type="datetimeFigureOut">
               <a:rPr lang="LID4096" smtClean="0"/>
-              <a:t>09/10/2025</a:t>
+              <a:t>09/15/2025</a:t>
             </a:fld>
             <a:endParaRPr lang="LID4096"/>
           </a:p>
@@ -1265,7 +1266,7 @@
           <a:p>
             <a:fld id="{6E06BE13-2967-499D-85E1-E8100B951B63}" type="datetimeFigureOut">
               <a:rPr lang="LID4096" smtClean="0"/>
-              <a:t>09/10/2025</a:t>
+              <a:t>09/15/2025</a:t>
             </a:fld>
             <a:endParaRPr lang="LID4096"/>
           </a:p>
@@ -1475,7 +1476,7 @@
           <a:p>
             <a:fld id="{6E06BE13-2967-499D-85E1-E8100B951B63}" type="datetimeFigureOut">
               <a:rPr lang="LID4096" smtClean="0"/>
-              <a:t>09/10/2025</a:t>
+              <a:t>09/15/2025</a:t>
             </a:fld>
             <a:endParaRPr lang="LID4096"/>
           </a:p>
@@ -1675,7 +1676,7 @@
           <a:p>
             <a:fld id="{6E06BE13-2967-499D-85E1-E8100B951B63}" type="datetimeFigureOut">
               <a:rPr lang="LID4096" smtClean="0"/>
-              <a:t>09/10/2025</a:t>
+              <a:t>09/15/2025</a:t>
             </a:fld>
             <a:endParaRPr lang="LID4096"/>
           </a:p>
@@ -1951,7 +1952,7 @@
           <a:p>
             <a:fld id="{6E06BE13-2967-499D-85E1-E8100B951B63}" type="datetimeFigureOut">
               <a:rPr lang="LID4096" smtClean="0"/>
-              <a:t>09/10/2025</a:t>
+              <a:t>09/15/2025</a:t>
             </a:fld>
             <a:endParaRPr lang="LID4096"/>
           </a:p>
@@ -2219,7 +2220,7 @@
           <a:p>
             <a:fld id="{6E06BE13-2967-499D-85E1-E8100B951B63}" type="datetimeFigureOut">
               <a:rPr lang="LID4096" smtClean="0"/>
-              <a:t>09/10/2025</a:t>
+              <a:t>09/15/2025</a:t>
             </a:fld>
             <a:endParaRPr lang="LID4096"/>
           </a:p>
@@ -2634,7 +2635,7 @@
           <a:p>
             <a:fld id="{6E06BE13-2967-499D-85E1-E8100B951B63}" type="datetimeFigureOut">
               <a:rPr lang="LID4096" smtClean="0"/>
-              <a:t>09/10/2025</a:t>
+              <a:t>09/15/2025</a:t>
             </a:fld>
             <a:endParaRPr lang="LID4096"/>
           </a:p>
@@ -2776,7 +2777,7 @@
           <a:p>
             <a:fld id="{6E06BE13-2967-499D-85E1-E8100B951B63}" type="datetimeFigureOut">
               <a:rPr lang="LID4096" smtClean="0"/>
-              <a:t>09/10/2025</a:t>
+              <a:t>09/15/2025</a:t>
             </a:fld>
             <a:endParaRPr lang="LID4096"/>
           </a:p>
@@ -2889,7 +2890,7 @@
           <a:p>
             <a:fld id="{6E06BE13-2967-499D-85E1-E8100B951B63}" type="datetimeFigureOut">
               <a:rPr lang="LID4096" smtClean="0"/>
-              <a:t>09/10/2025</a:t>
+              <a:t>09/15/2025</a:t>
             </a:fld>
             <a:endParaRPr lang="LID4096"/>
           </a:p>
@@ -3202,7 +3203,7 @@
           <a:p>
             <a:fld id="{6E06BE13-2967-499D-85E1-E8100B951B63}" type="datetimeFigureOut">
               <a:rPr lang="LID4096" smtClean="0"/>
-              <a:t>09/10/2025</a:t>
+              <a:t>09/15/2025</a:t>
             </a:fld>
             <a:endParaRPr lang="LID4096"/>
           </a:p>
@@ -3491,7 +3492,7 @@
           <a:p>
             <a:fld id="{6E06BE13-2967-499D-85E1-E8100B951B63}" type="datetimeFigureOut">
               <a:rPr lang="LID4096" smtClean="0"/>
-              <a:t>09/10/2025</a:t>
+              <a:t>09/15/2025</a:t>
             </a:fld>
             <a:endParaRPr lang="LID4096"/>
           </a:p>
@@ -3734,7 +3735,7 @@
           <a:p>
             <a:fld id="{6E06BE13-2967-499D-85E1-E8100B951B63}" type="datetimeFigureOut">
               <a:rPr lang="LID4096" smtClean="0"/>
-              <a:t>09/10/2025</a:t>
+              <a:t>09/15/2025</a:t>
             </a:fld>
             <a:endParaRPr lang="LID4096"/>
           </a:p>
@@ -19345,6 +19346,2309 @@
     <p:extLst>
       <p:ext uri="{BB962C8B-B14F-4D97-AF65-F5344CB8AC3E}">
         <p14:creationId xmlns:p14="http://schemas.microsoft.com/office/powerpoint/2010/main" val="1859187612"/>
+      </p:ext>
+    </p:extLst>
+  </p:cSld>
+  <p:clrMapOvr>
+    <a:masterClrMapping/>
+  </p:clrMapOvr>
+</p:sld>
+</file>
+
+<file path=ppt/slides/slide6.xml><?xml version="1.0" encoding="utf-8"?>
+<p:sld xmlns:a="http://schemas.openxmlformats.org/drawingml/2006/main" xmlns:r="http://schemas.openxmlformats.org/officeDocument/2006/relationships" xmlns:p="http://schemas.openxmlformats.org/presentationml/2006/main">
+  <p:cSld>
+    <p:spTree>
+      <p:nvGrpSpPr>
+        <p:cNvPr id="1" name=""/>
+        <p:cNvGrpSpPr/>
+        <p:nvPr/>
+      </p:nvGrpSpPr>
+      <p:grpSpPr>
+        <a:xfrm>
+          <a:off x="0" y="0"/>
+          <a:ext cx="0" cy="0"/>
+          <a:chOff x="0" y="0"/>
+          <a:chExt cx="0" cy="0"/>
+        </a:xfrm>
+      </p:grpSpPr>
+      <p:sp>
+        <p:nvSpPr>
+          <p:cNvPr id="6" name="Rectangle 5">
+            <a:extLst>
+              <a:ext uri="{FF2B5EF4-FFF2-40B4-BE49-F238E27FC236}">
+                <a16:creationId xmlns:a16="http://schemas.microsoft.com/office/drawing/2014/main" id="{25B9F360-8B2F-9EE9-62FE-A63C35873815}"/>
+              </a:ext>
+            </a:extLst>
+          </p:cNvPr>
+          <p:cNvSpPr/>
+          <p:nvPr/>
+        </p:nvSpPr>
+        <p:spPr>
+          <a:xfrm>
+            <a:off x="1916769" y="1502679"/>
+            <a:ext cx="1256492" cy="231131"/>
+          </a:xfrm>
+          <a:prstGeom prst="rect">
+            <a:avLst/>
+          </a:prstGeom>
+          <a:noFill/>
+          <a:ln>
+            <a:solidFill>
+              <a:schemeClr val="bg1">
+                <a:lumMod val="65000"/>
+              </a:schemeClr>
+            </a:solidFill>
+          </a:ln>
+        </p:spPr>
+        <p:style>
+          <a:lnRef idx="2">
+            <a:schemeClr val="accent1">
+              <a:shade val="15000"/>
+            </a:schemeClr>
+          </a:lnRef>
+          <a:fillRef idx="1">
+            <a:schemeClr val="accent1"/>
+          </a:fillRef>
+          <a:effectRef idx="0">
+            <a:schemeClr val="accent1"/>
+          </a:effectRef>
+          <a:fontRef idx="minor">
+            <a:schemeClr val="lt1"/>
+          </a:fontRef>
+        </p:style>
+        <p:txBody>
+          <a:bodyPr rtlCol="0" anchor="ctr"/>
+          <a:lstStyle/>
+          <a:p>
+            <a:pPr algn="ctr"/>
+            <a:endParaRPr lang="LID4096"/>
+          </a:p>
+        </p:txBody>
+      </p:sp>
+      <p:sp>
+        <p:nvSpPr>
+          <p:cNvPr id="2" name="Rectangle 1">
+            <a:extLst>
+              <a:ext uri="{FF2B5EF4-FFF2-40B4-BE49-F238E27FC236}">
+                <a16:creationId xmlns:a16="http://schemas.microsoft.com/office/drawing/2014/main" id="{1D31DE08-D7C0-3E0A-7DC2-F93B8AEE085A}"/>
+              </a:ext>
+            </a:extLst>
+          </p:cNvPr>
+          <p:cNvSpPr/>
+          <p:nvPr/>
+        </p:nvSpPr>
+        <p:spPr>
+          <a:xfrm>
+            <a:off x="1916769" y="1727104"/>
+            <a:ext cx="1256492" cy="231131"/>
+          </a:xfrm>
+          <a:prstGeom prst="rect">
+            <a:avLst/>
+          </a:prstGeom>
+          <a:noFill/>
+          <a:ln>
+            <a:solidFill>
+              <a:schemeClr val="bg1">
+                <a:lumMod val="65000"/>
+              </a:schemeClr>
+            </a:solidFill>
+          </a:ln>
+        </p:spPr>
+        <p:style>
+          <a:lnRef idx="2">
+            <a:schemeClr val="accent1">
+              <a:shade val="15000"/>
+            </a:schemeClr>
+          </a:lnRef>
+          <a:fillRef idx="1">
+            <a:schemeClr val="accent1"/>
+          </a:fillRef>
+          <a:effectRef idx="0">
+            <a:schemeClr val="accent1"/>
+          </a:effectRef>
+          <a:fontRef idx="minor">
+            <a:schemeClr val="lt1"/>
+          </a:fontRef>
+        </p:style>
+        <p:txBody>
+          <a:bodyPr rtlCol="0" anchor="ctr"/>
+          <a:lstStyle/>
+          <a:p>
+            <a:pPr algn="ctr"/>
+            <a:endParaRPr lang="LID4096"/>
+          </a:p>
+        </p:txBody>
+      </p:sp>
+      <p:sp>
+        <p:nvSpPr>
+          <p:cNvPr id="3" name="TextBox 2">
+            <a:extLst>
+              <a:ext uri="{FF2B5EF4-FFF2-40B4-BE49-F238E27FC236}">
+                <a16:creationId xmlns:a16="http://schemas.microsoft.com/office/drawing/2014/main" id="{F947A3C6-371E-F6EB-9ADD-DCE68759E86E}"/>
+              </a:ext>
+            </a:extLst>
+          </p:cNvPr>
+          <p:cNvSpPr txBox="1"/>
+          <p:nvPr/>
+        </p:nvSpPr>
+        <p:spPr>
+          <a:xfrm>
+            <a:off x="3173261" y="1723905"/>
+            <a:ext cx="954107" cy="261610"/>
+          </a:xfrm>
+          <a:prstGeom prst="rect">
+            <a:avLst/>
+          </a:prstGeom>
+          <a:noFill/>
+        </p:spPr>
+        <p:txBody>
+          <a:bodyPr wrap="none" rtlCol="0">
+            <a:spAutoFit/>
+          </a:bodyPr>
+          <a:lstStyle/>
+          <a:p>
+            <a:r>
+              <a:rPr lang="en-GB" sz="1050">
+                <a:latin typeface="Consolas" panose="020B0609020204030204" pitchFamily="49" charset="0"/>
+              </a:rPr>
+              <a:t>0x20010000</a:t>
+            </a:r>
+            <a:endParaRPr lang="LID4096" sz="1050">
+              <a:latin typeface="Consolas" panose="020B0609020204030204" pitchFamily="49" charset="0"/>
+            </a:endParaRPr>
+          </a:p>
+        </p:txBody>
+      </p:sp>
+      <p:sp>
+        <p:nvSpPr>
+          <p:cNvPr id="7" name="TextBox 6">
+            <a:extLst>
+              <a:ext uri="{FF2B5EF4-FFF2-40B4-BE49-F238E27FC236}">
+                <a16:creationId xmlns:a16="http://schemas.microsoft.com/office/drawing/2014/main" id="{EB66036B-660C-E9BF-9740-69C4753231B5}"/>
+              </a:ext>
+            </a:extLst>
+          </p:cNvPr>
+          <p:cNvSpPr txBox="1"/>
+          <p:nvPr/>
+        </p:nvSpPr>
+        <p:spPr>
+          <a:xfrm>
+            <a:off x="3173261" y="1491707"/>
+            <a:ext cx="922047" cy="253916"/>
+          </a:xfrm>
+          <a:prstGeom prst="rect">
+            <a:avLst/>
+          </a:prstGeom>
+          <a:noFill/>
+        </p:spPr>
+        <p:txBody>
+          <a:bodyPr wrap="none" rtlCol="0">
+            <a:spAutoFit/>
+          </a:bodyPr>
+          <a:lstStyle/>
+          <a:p>
+            <a:r>
+              <a:rPr lang="en-GB" sz="1050">
+                <a:solidFill>
+                  <a:schemeClr val="bg1">
+                    <a:lumMod val="65000"/>
+                  </a:schemeClr>
+                </a:solidFill>
+                <a:latin typeface="Consolas" panose="020B0609020204030204" pitchFamily="49" charset="0"/>
+              </a:rPr>
+              <a:t>0x20010004</a:t>
+            </a:r>
+            <a:endParaRPr lang="LID4096" sz="1050">
+              <a:solidFill>
+                <a:schemeClr val="bg1">
+                  <a:lumMod val="65000"/>
+                </a:schemeClr>
+              </a:solidFill>
+              <a:latin typeface="Consolas" panose="020B0609020204030204" pitchFamily="49" charset="0"/>
+            </a:endParaRPr>
+          </a:p>
+        </p:txBody>
+      </p:sp>
+      <p:sp>
+        <p:nvSpPr>
+          <p:cNvPr id="9" name="Rectangle 8">
+            <a:extLst>
+              <a:ext uri="{FF2B5EF4-FFF2-40B4-BE49-F238E27FC236}">
+                <a16:creationId xmlns:a16="http://schemas.microsoft.com/office/drawing/2014/main" id="{3B26D6C5-DF11-A6A2-4FCD-4FD75F19F5B6}"/>
+              </a:ext>
+            </a:extLst>
+          </p:cNvPr>
+          <p:cNvSpPr/>
+          <p:nvPr/>
+        </p:nvSpPr>
+        <p:spPr>
+          <a:xfrm>
+            <a:off x="1916769" y="2185859"/>
+            <a:ext cx="1256492" cy="231131"/>
+          </a:xfrm>
+          <a:prstGeom prst="rect">
+            <a:avLst/>
+          </a:prstGeom>
+          <a:solidFill>
+            <a:schemeClr val="bg1">
+              <a:lumMod val="85000"/>
+            </a:schemeClr>
+          </a:solidFill>
+        </p:spPr>
+        <p:style>
+          <a:lnRef idx="2">
+            <a:schemeClr val="accent1">
+              <a:shade val="15000"/>
+            </a:schemeClr>
+          </a:lnRef>
+          <a:fillRef idx="1">
+            <a:schemeClr val="accent1"/>
+          </a:fillRef>
+          <a:effectRef idx="0">
+            <a:schemeClr val="accent1"/>
+          </a:effectRef>
+          <a:fontRef idx="minor">
+            <a:schemeClr val="lt1"/>
+          </a:fontRef>
+        </p:style>
+        <p:txBody>
+          <a:bodyPr rtlCol="0" anchor="ctr"/>
+          <a:lstStyle/>
+          <a:p>
+            <a:pPr algn="ctr"/>
+            <a:endParaRPr lang="LID4096"/>
+          </a:p>
+        </p:txBody>
+      </p:sp>
+      <p:sp>
+        <p:nvSpPr>
+          <p:cNvPr id="10" name="TextBox 9">
+            <a:extLst>
+              <a:ext uri="{FF2B5EF4-FFF2-40B4-BE49-F238E27FC236}">
+                <a16:creationId xmlns:a16="http://schemas.microsoft.com/office/drawing/2014/main" id="{5F87AD07-C549-0056-4197-4C5917307A52}"/>
+              </a:ext>
+            </a:extLst>
+          </p:cNvPr>
+          <p:cNvSpPr txBox="1"/>
+          <p:nvPr/>
+        </p:nvSpPr>
+        <p:spPr>
+          <a:xfrm>
+            <a:off x="3173261" y="2182660"/>
+            <a:ext cx="922047" cy="253916"/>
+          </a:xfrm>
+          <a:prstGeom prst="rect">
+            <a:avLst/>
+          </a:prstGeom>
+          <a:noFill/>
+        </p:spPr>
+        <p:txBody>
+          <a:bodyPr wrap="none" rtlCol="0">
+            <a:spAutoFit/>
+          </a:bodyPr>
+          <a:lstStyle/>
+          <a:p>
+            <a:r>
+              <a:rPr lang="en-GB" sz="1050">
+                <a:latin typeface="Consolas" panose="020B0609020204030204" pitchFamily="49" charset="0"/>
+              </a:rPr>
+              <a:t>0x2000FFF8</a:t>
+            </a:r>
+            <a:endParaRPr lang="LID4096" sz="1050">
+              <a:latin typeface="Consolas" panose="020B0609020204030204" pitchFamily="49" charset="0"/>
+            </a:endParaRPr>
+          </a:p>
+        </p:txBody>
+      </p:sp>
+      <p:sp>
+        <p:nvSpPr>
+          <p:cNvPr id="11" name="Rectangle 10">
+            <a:extLst>
+              <a:ext uri="{FF2B5EF4-FFF2-40B4-BE49-F238E27FC236}">
+                <a16:creationId xmlns:a16="http://schemas.microsoft.com/office/drawing/2014/main" id="{A0D7F36B-4F17-7A74-6520-A67C95F6397F}"/>
+              </a:ext>
+            </a:extLst>
+          </p:cNvPr>
+          <p:cNvSpPr/>
+          <p:nvPr/>
+        </p:nvSpPr>
+        <p:spPr>
+          <a:xfrm>
+            <a:off x="1916769" y="1961434"/>
+            <a:ext cx="1256492" cy="231131"/>
+          </a:xfrm>
+          <a:prstGeom prst="rect">
+            <a:avLst/>
+          </a:prstGeom>
+          <a:solidFill>
+            <a:schemeClr val="bg1">
+              <a:lumMod val="85000"/>
+            </a:schemeClr>
+          </a:solidFill>
+        </p:spPr>
+        <p:style>
+          <a:lnRef idx="2">
+            <a:schemeClr val="accent1">
+              <a:shade val="15000"/>
+            </a:schemeClr>
+          </a:lnRef>
+          <a:fillRef idx="1">
+            <a:schemeClr val="accent1"/>
+          </a:fillRef>
+          <a:effectRef idx="0">
+            <a:schemeClr val="accent1"/>
+          </a:effectRef>
+          <a:fontRef idx="minor">
+            <a:schemeClr val="lt1"/>
+          </a:fontRef>
+        </p:style>
+        <p:txBody>
+          <a:bodyPr rtlCol="0" anchor="ctr"/>
+          <a:lstStyle/>
+          <a:p>
+            <a:pPr algn="ctr"/>
+            <a:endParaRPr lang="LID4096"/>
+          </a:p>
+        </p:txBody>
+      </p:sp>
+      <p:sp>
+        <p:nvSpPr>
+          <p:cNvPr id="12" name="TextBox 11">
+            <a:extLst>
+              <a:ext uri="{FF2B5EF4-FFF2-40B4-BE49-F238E27FC236}">
+                <a16:creationId xmlns:a16="http://schemas.microsoft.com/office/drawing/2014/main" id="{E1F502B8-130D-B303-C4AE-81B603ACBB6C}"/>
+              </a:ext>
+            </a:extLst>
+          </p:cNvPr>
+          <p:cNvSpPr txBox="1"/>
+          <p:nvPr/>
+        </p:nvSpPr>
+        <p:spPr>
+          <a:xfrm>
+            <a:off x="3173261" y="1950462"/>
+            <a:ext cx="922047" cy="253916"/>
+          </a:xfrm>
+          <a:prstGeom prst="rect">
+            <a:avLst/>
+          </a:prstGeom>
+          <a:noFill/>
+        </p:spPr>
+        <p:txBody>
+          <a:bodyPr wrap="none" rtlCol="0">
+            <a:spAutoFit/>
+          </a:bodyPr>
+          <a:lstStyle/>
+          <a:p>
+            <a:r>
+              <a:rPr lang="en-GB" sz="1050">
+                <a:latin typeface="Consolas" panose="020B0609020204030204" pitchFamily="49" charset="0"/>
+              </a:rPr>
+              <a:t>0x2000FFFC</a:t>
+            </a:r>
+            <a:endParaRPr lang="LID4096" sz="1050">
+              <a:latin typeface="Consolas" panose="020B0609020204030204" pitchFamily="49" charset="0"/>
+            </a:endParaRPr>
+          </a:p>
+        </p:txBody>
+      </p:sp>
+      <p:sp>
+        <p:nvSpPr>
+          <p:cNvPr id="14" name="Rectangle 13">
+            <a:extLst>
+              <a:ext uri="{FF2B5EF4-FFF2-40B4-BE49-F238E27FC236}">
+                <a16:creationId xmlns:a16="http://schemas.microsoft.com/office/drawing/2014/main" id="{FC3A8E9C-E657-DDB1-978E-0CAC2B997D2A}"/>
+              </a:ext>
+            </a:extLst>
+          </p:cNvPr>
+          <p:cNvSpPr/>
+          <p:nvPr/>
+        </p:nvSpPr>
+        <p:spPr>
+          <a:xfrm>
+            <a:off x="1916769" y="2644614"/>
+            <a:ext cx="1256492" cy="231131"/>
+          </a:xfrm>
+          <a:prstGeom prst="rect">
+            <a:avLst/>
+          </a:prstGeom>
+          <a:solidFill>
+            <a:schemeClr val="bg1">
+              <a:lumMod val="85000"/>
+            </a:schemeClr>
+          </a:solidFill>
+        </p:spPr>
+        <p:style>
+          <a:lnRef idx="2">
+            <a:schemeClr val="accent1">
+              <a:shade val="15000"/>
+            </a:schemeClr>
+          </a:lnRef>
+          <a:fillRef idx="1">
+            <a:schemeClr val="accent1"/>
+          </a:fillRef>
+          <a:effectRef idx="0">
+            <a:schemeClr val="accent1"/>
+          </a:effectRef>
+          <a:fontRef idx="minor">
+            <a:schemeClr val="lt1"/>
+          </a:fontRef>
+        </p:style>
+        <p:txBody>
+          <a:bodyPr rtlCol="0" anchor="ctr"/>
+          <a:lstStyle/>
+          <a:p>
+            <a:pPr algn="ctr"/>
+            <a:endParaRPr lang="LID4096"/>
+          </a:p>
+        </p:txBody>
+      </p:sp>
+      <p:sp>
+        <p:nvSpPr>
+          <p:cNvPr id="15" name="TextBox 14">
+            <a:extLst>
+              <a:ext uri="{FF2B5EF4-FFF2-40B4-BE49-F238E27FC236}">
+                <a16:creationId xmlns:a16="http://schemas.microsoft.com/office/drawing/2014/main" id="{7B0854C5-A81C-6672-31D5-0747F90EB254}"/>
+              </a:ext>
+            </a:extLst>
+          </p:cNvPr>
+          <p:cNvSpPr txBox="1"/>
+          <p:nvPr/>
+        </p:nvSpPr>
+        <p:spPr>
+          <a:xfrm>
+            <a:off x="3173261" y="2641415"/>
+            <a:ext cx="922047" cy="253916"/>
+          </a:xfrm>
+          <a:prstGeom prst="rect">
+            <a:avLst/>
+          </a:prstGeom>
+          <a:noFill/>
+        </p:spPr>
+        <p:txBody>
+          <a:bodyPr wrap="none" rtlCol="0">
+            <a:spAutoFit/>
+          </a:bodyPr>
+          <a:lstStyle/>
+          <a:p>
+            <a:r>
+              <a:rPr lang="en-GB" sz="1050">
+                <a:latin typeface="Consolas" panose="020B0609020204030204" pitchFamily="49" charset="0"/>
+              </a:rPr>
+              <a:t>0x2000FFF0</a:t>
+            </a:r>
+            <a:endParaRPr lang="LID4096" sz="1050">
+              <a:latin typeface="Consolas" panose="020B0609020204030204" pitchFamily="49" charset="0"/>
+            </a:endParaRPr>
+          </a:p>
+        </p:txBody>
+      </p:sp>
+      <p:sp>
+        <p:nvSpPr>
+          <p:cNvPr id="16" name="Rectangle 15">
+            <a:extLst>
+              <a:ext uri="{FF2B5EF4-FFF2-40B4-BE49-F238E27FC236}">
+                <a16:creationId xmlns:a16="http://schemas.microsoft.com/office/drawing/2014/main" id="{E2FDF3AC-C5E1-1658-7995-26F35FDC5FE1}"/>
+              </a:ext>
+            </a:extLst>
+          </p:cNvPr>
+          <p:cNvSpPr/>
+          <p:nvPr/>
+        </p:nvSpPr>
+        <p:spPr>
+          <a:xfrm>
+            <a:off x="1916769" y="2420189"/>
+            <a:ext cx="1256492" cy="231131"/>
+          </a:xfrm>
+          <a:prstGeom prst="rect">
+            <a:avLst/>
+          </a:prstGeom>
+          <a:solidFill>
+            <a:schemeClr val="bg1">
+              <a:lumMod val="85000"/>
+            </a:schemeClr>
+          </a:solidFill>
+        </p:spPr>
+        <p:style>
+          <a:lnRef idx="2">
+            <a:schemeClr val="accent1">
+              <a:shade val="15000"/>
+            </a:schemeClr>
+          </a:lnRef>
+          <a:fillRef idx="1">
+            <a:schemeClr val="accent1"/>
+          </a:fillRef>
+          <a:effectRef idx="0">
+            <a:schemeClr val="accent1"/>
+          </a:effectRef>
+          <a:fontRef idx="minor">
+            <a:schemeClr val="lt1"/>
+          </a:fontRef>
+        </p:style>
+        <p:txBody>
+          <a:bodyPr rtlCol="0" anchor="ctr"/>
+          <a:lstStyle/>
+          <a:p>
+            <a:pPr algn="ctr"/>
+            <a:endParaRPr lang="LID4096"/>
+          </a:p>
+        </p:txBody>
+      </p:sp>
+      <p:sp>
+        <p:nvSpPr>
+          <p:cNvPr id="17" name="TextBox 16">
+            <a:extLst>
+              <a:ext uri="{FF2B5EF4-FFF2-40B4-BE49-F238E27FC236}">
+                <a16:creationId xmlns:a16="http://schemas.microsoft.com/office/drawing/2014/main" id="{E0CBEC8B-042E-7699-5A52-A725F872363B}"/>
+              </a:ext>
+            </a:extLst>
+          </p:cNvPr>
+          <p:cNvSpPr txBox="1"/>
+          <p:nvPr/>
+        </p:nvSpPr>
+        <p:spPr>
+          <a:xfrm>
+            <a:off x="3173261" y="2409217"/>
+            <a:ext cx="922047" cy="253916"/>
+          </a:xfrm>
+          <a:prstGeom prst="rect">
+            <a:avLst/>
+          </a:prstGeom>
+          <a:noFill/>
+        </p:spPr>
+        <p:txBody>
+          <a:bodyPr wrap="none" rtlCol="0">
+            <a:spAutoFit/>
+          </a:bodyPr>
+          <a:lstStyle/>
+          <a:p>
+            <a:r>
+              <a:rPr lang="en-GB" sz="1050">
+                <a:latin typeface="Consolas" panose="020B0609020204030204" pitchFamily="49" charset="0"/>
+              </a:rPr>
+              <a:t>0x2000FFF4</a:t>
+            </a:r>
+            <a:endParaRPr lang="LID4096" sz="1050">
+              <a:latin typeface="Consolas" panose="020B0609020204030204" pitchFamily="49" charset="0"/>
+            </a:endParaRPr>
+          </a:p>
+        </p:txBody>
+      </p:sp>
+      <p:sp>
+        <p:nvSpPr>
+          <p:cNvPr id="19" name="TextBox 18">
+            <a:extLst>
+              <a:ext uri="{FF2B5EF4-FFF2-40B4-BE49-F238E27FC236}">
+                <a16:creationId xmlns:a16="http://schemas.microsoft.com/office/drawing/2014/main" id="{1661788E-A6AA-375C-8528-2A3990D6CDFE}"/>
+              </a:ext>
+            </a:extLst>
+          </p:cNvPr>
+          <p:cNvSpPr txBox="1"/>
+          <p:nvPr/>
+        </p:nvSpPr>
+        <p:spPr>
+          <a:xfrm>
+            <a:off x="3173261" y="1018928"/>
+            <a:ext cx="1290738" cy="484748"/>
+          </a:xfrm>
+          <a:prstGeom prst="rect">
+            <a:avLst/>
+          </a:prstGeom>
+          <a:noFill/>
+        </p:spPr>
+        <p:txBody>
+          <a:bodyPr wrap="none" rtlCol="0">
+            <a:spAutoFit/>
+          </a:bodyPr>
+          <a:lstStyle/>
+          <a:p>
+            <a:r>
+              <a:rPr lang="en-GB" sz="1050" b="1">
+                <a:latin typeface="Consolas" panose="020B0609020204030204" pitchFamily="49" charset="0"/>
+              </a:rPr>
+              <a:t>sp</a:t>
+            </a:r>
+            <a:r>
+              <a:rPr lang="en-GB" sz="1050">
+                <a:latin typeface="Consolas" panose="020B0609020204030204" pitchFamily="49" charset="0"/>
+              </a:rPr>
+              <a:t> = 0x20010000</a:t>
+            </a:r>
+          </a:p>
+          <a:p>
+            <a:pPr algn="ctr"/>
+            <a:r>
+              <a:rPr lang="en-GB" sz="500">
+                <a:latin typeface="Consolas" panose="020B0609020204030204" pitchFamily="49" charset="0"/>
+              </a:rPr>
+              <a:t>= &lt;bottom of stack&gt;</a:t>
+            </a:r>
+          </a:p>
+          <a:p>
+            <a:pPr algn="ctr"/>
+            <a:r>
+              <a:rPr lang="en-GB" sz="500">
+                <a:latin typeface="Consolas" panose="020B0609020204030204" pitchFamily="49" charset="0"/>
+              </a:rPr>
+              <a:t>= &lt;top of stack&gt;</a:t>
+            </a:r>
+          </a:p>
+          <a:p>
+            <a:pPr algn="ctr"/>
+            <a:endParaRPr lang="en-GB" sz="500">
+              <a:latin typeface="Consolas" panose="020B0609020204030204" pitchFamily="49" charset="0"/>
+            </a:endParaRPr>
+          </a:p>
+        </p:txBody>
+      </p:sp>
+      <p:sp>
+        <p:nvSpPr>
+          <p:cNvPr id="20" name="Arrow: Bent 19">
+            <a:extLst>
+              <a:ext uri="{FF2B5EF4-FFF2-40B4-BE49-F238E27FC236}">
+                <a16:creationId xmlns:a16="http://schemas.microsoft.com/office/drawing/2014/main" id="{8F76212D-ACBE-EC6D-0BFF-CF5D25DDE062}"/>
+              </a:ext>
+            </a:extLst>
+          </p:cNvPr>
+          <p:cNvSpPr/>
+          <p:nvPr/>
+        </p:nvSpPr>
+        <p:spPr>
+          <a:xfrm flipH="1" flipV="1">
+            <a:off x="4062610" y="1306659"/>
+            <a:ext cx="304800" cy="623170"/>
+          </a:xfrm>
+          <a:prstGeom prst="bentArrow">
+            <a:avLst/>
+          </a:prstGeom>
+          <a:solidFill>
+            <a:schemeClr val="bg1">
+              <a:lumMod val="85000"/>
+            </a:schemeClr>
+          </a:solidFill>
+          <a:ln w="12700">
+            <a:solidFill>
+              <a:schemeClr val="tx1"/>
+            </a:solidFill>
+          </a:ln>
+        </p:spPr>
+        <p:style>
+          <a:lnRef idx="2">
+            <a:schemeClr val="accent1">
+              <a:shade val="15000"/>
+            </a:schemeClr>
+          </a:lnRef>
+          <a:fillRef idx="1">
+            <a:schemeClr val="accent1"/>
+          </a:fillRef>
+          <a:effectRef idx="0">
+            <a:schemeClr val="accent1"/>
+          </a:effectRef>
+          <a:fontRef idx="minor">
+            <a:schemeClr val="lt1"/>
+          </a:fontRef>
+        </p:style>
+        <p:txBody>
+          <a:bodyPr rtlCol="0" anchor="ctr"/>
+          <a:lstStyle/>
+          <a:p>
+            <a:pPr algn="ctr"/>
+            <a:endParaRPr lang="LID4096">
+              <a:solidFill>
+                <a:schemeClr val="tx1"/>
+              </a:solidFill>
+            </a:endParaRPr>
+          </a:p>
+        </p:txBody>
+      </p:sp>
+      <p:sp>
+        <p:nvSpPr>
+          <p:cNvPr id="21" name="Rectangle 20">
+            <a:extLst>
+              <a:ext uri="{FF2B5EF4-FFF2-40B4-BE49-F238E27FC236}">
+                <a16:creationId xmlns:a16="http://schemas.microsoft.com/office/drawing/2014/main" id="{0844AD97-B912-D5AA-A96B-BE75FFEDF499}"/>
+              </a:ext>
+            </a:extLst>
+          </p:cNvPr>
+          <p:cNvSpPr/>
+          <p:nvPr/>
+        </p:nvSpPr>
+        <p:spPr>
+          <a:xfrm>
+            <a:off x="4979381" y="1483093"/>
+            <a:ext cx="1256492" cy="231131"/>
+          </a:xfrm>
+          <a:prstGeom prst="rect">
+            <a:avLst/>
+          </a:prstGeom>
+          <a:noFill/>
+          <a:ln>
+            <a:solidFill>
+              <a:schemeClr val="bg1">
+                <a:lumMod val="65000"/>
+              </a:schemeClr>
+            </a:solidFill>
+          </a:ln>
+        </p:spPr>
+        <p:style>
+          <a:lnRef idx="2">
+            <a:schemeClr val="accent1">
+              <a:shade val="15000"/>
+            </a:schemeClr>
+          </a:lnRef>
+          <a:fillRef idx="1">
+            <a:schemeClr val="accent1"/>
+          </a:fillRef>
+          <a:effectRef idx="0">
+            <a:schemeClr val="accent1"/>
+          </a:effectRef>
+          <a:fontRef idx="minor">
+            <a:schemeClr val="lt1"/>
+          </a:fontRef>
+        </p:style>
+        <p:txBody>
+          <a:bodyPr rtlCol="0" anchor="ctr"/>
+          <a:lstStyle/>
+          <a:p>
+            <a:pPr algn="ctr"/>
+            <a:endParaRPr lang="LID4096"/>
+          </a:p>
+        </p:txBody>
+      </p:sp>
+      <p:sp>
+        <p:nvSpPr>
+          <p:cNvPr id="22" name="Rectangle 21">
+            <a:extLst>
+              <a:ext uri="{FF2B5EF4-FFF2-40B4-BE49-F238E27FC236}">
+                <a16:creationId xmlns:a16="http://schemas.microsoft.com/office/drawing/2014/main" id="{385316FD-E832-922F-DED2-0608DF787AA8}"/>
+              </a:ext>
+            </a:extLst>
+          </p:cNvPr>
+          <p:cNvSpPr/>
+          <p:nvPr/>
+        </p:nvSpPr>
+        <p:spPr>
+          <a:xfrm>
+            <a:off x="4979381" y="1707518"/>
+            <a:ext cx="1256492" cy="231131"/>
+          </a:xfrm>
+          <a:prstGeom prst="rect">
+            <a:avLst/>
+          </a:prstGeom>
+          <a:noFill/>
+          <a:ln>
+            <a:solidFill>
+              <a:schemeClr val="bg1">
+                <a:lumMod val="65000"/>
+              </a:schemeClr>
+            </a:solidFill>
+          </a:ln>
+        </p:spPr>
+        <p:style>
+          <a:lnRef idx="2">
+            <a:schemeClr val="accent1">
+              <a:shade val="15000"/>
+            </a:schemeClr>
+          </a:lnRef>
+          <a:fillRef idx="1">
+            <a:schemeClr val="accent1"/>
+          </a:fillRef>
+          <a:effectRef idx="0">
+            <a:schemeClr val="accent1"/>
+          </a:effectRef>
+          <a:fontRef idx="minor">
+            <a:schemeClr val="lt1"/>
+          </a:fontRef>
+        </p:style>
+        <p:txBody>
+          <a:bodyPr rtlCol="0" anchor="ctr"/>
+          <a:lstStyle/>
+          <a:p>
+            <a:pPr algn="ctr"/>
+            <a:endParaRPr lang="LID4096"/>
+          </a:p>
+        </p:txBody>
+      </p:sp>
+      <p:sp>
+        <p:nvSpPr>
+          <p:cNvPr id="23" name="TextBox 22">
+            <a:extLst>
+              <a:ext uri="{FF2B5EF4-FFF2-40B4-BE49-F238E27FC236}">
+                <a16:creationId xmlns:a16="http://schemas.microsoft.com/office/drawing/2014/main" id="{79A7E8B7-9B51-7A6B-86E8-EDC37E717772}"/>
+              </a:ext>
+            </a:extLst>
+          </p:cNvPr>
+          <p:cNvSpPr txBox="1"/>
+          <p:nvPr/>
+        </p:nvSpPr>
+        <p:spPr>
+          <a:xfrm>
+            <a:off x="6235873" y="1704319"/>
+            <a:ext cx="954107" cy="261610"/>
+          </a:xfrm>
+          <a:prstGeom prst="rect">
+            <a:avLst/>
+          </a:prstGeom>
+          <a:noFill/>
+        </p:spPr>
+        <p:txBody>
+          <a:bodyPr wrap="none" rtlCol="0">
+            <a:spAutoFit/>
+          </a:bodyPr>
+          <a:lstStyle/>
+          <a:p>
+            <a:r>
+              <a:rPr lang="en-GB" sz="1050">
+                <a:latin typeface="Consolas" panose="020B0609020204030204" pitchFamily="49" charset="0"/>
+              </a:rPr>
+              <a:t>0x20010000</a:t>
+            </a:r>
+            <a:endParaRPr lang="LID4096" sz="1050">
+              <a:latin typeface="Consolas" panose="020B0609020204030204" pitchFamily="49" charset="0"/>
+            </a:endParaRPr>
+          </a:p>
+        </p:txBody>
+      </p:sp>
+      <p:sp>
+        <p:nvSpPr>
+          <p:cNvPr id="24" name="TextBox 23">
+            <a:extLst>
+              <a:ext uri="{FF2B5EF4-FFF2-40B4-BE49-F238E27FC236}">
+                <a16:creationId xmlns:a16="http://schemas.microsoft.com/office/drawing/2014/main" id="{02B9E8E9-19AA-E4B7-DFB7-12010124D8C2}"/>
+              </a:ext>
+            </a:extLst>
+          </p:cNvPr>
+          <p:cNvSpPr txBox="1"/>
+          <p:nvPr/>
+        </p:nvSpPr>
+        <p:spPr>
+          <a:xfrm>
+            <a:off x="6235873" y="1472121"/>
+            <a:ext cx="922047" cy="253916"/>
+          </a:xfrm>
+          <a:prstGeom prst="rect">
+            <a:avLst/>
+          </a:prstGeom>
+          <a:noFill/>
+        </p:spPr>
+        <p:txBody>
+          <a:bodyPr wrap="none" rtlCol="0">
+            <a:spAutoFit/>
+          </a:bodyPr>
+          <a:lstStyle/>
+          <a:p>
+            <a:r>
+              <a:rPr lang="en-GB" sz="1050">
+                <a:solidFill>
+                  <a:schemeClr val="bg1">
+                    <a:lumMod val="65000"/>
+                  </a:schemeClr>
+                </a:solidFill>
+                <a:latin typeface="Consolas" panose="020B0609020204030204" pitchFamily="49" charset="0"/>
+              </a:rPr>
+              <a:t>0x20010004</a:t>
+            </a:r>
+            <a:endParaRPr lang="LID4096" sz="1050">
+              <a:solidFill>
+                <a:schemeClr val="bg1">
+                  <a:lumMod val="65000"/>
+                </a:schemeClr>
+              </a:solidFill>
+              <a:latin typeface="Consolas" panose="020B0609020204030204" pitchFamily="49" charset="0"/>
+            </a:endParaRPr>
+          </a:p>
+        </p:txBody>
+      </p:sp>
+      <p:sp>
+        <p:nvSpPr>
+          <p:cNvPr id="26" name="Rectangle 25">
+            <a:extLst>
+              <a:ext uri="{FF2B5EF4-FFF2-40B4-BE49-F238E27FC236}">
+                <a16:creationId xmlns:a16="http://schemas.microsoft.com/office/drawing/2014/main" id="{5840FBC5-A57D-304C-D9A1-E785D773075A}"/>
+              </a:ext>
+            </a:extLst>
+          </p:cNvPr>
+          <p:cNvSpPr/>
+          <p:nvPr/>
+        </p:nvSpPr>
+        <p:spPr>
+          <a:xfrm>
+            <a:off x="4979381" y="2166273"/>
+            <a:ext cx="1256492" cy="231131"/>
+          </a:xfrm>
+          <a:prstGeom prst="rect">
+            <a:avLst/>
+          </a:prstGeom>
+          <a:noFill/>
+        </p:spPr>
+        <p:style>
+          <a:lnRef idx="2">
+            <a:schemeClr val="accent1">
+              <a:shade val="15000"/>
+            </a:schemeClr>
+          </a:lnRef>
+          <a:fillRef idx="1">
+            <a:schemeClr val="accent1"/>
+          </a:fillRef>
+          <a:effectRef idx="0">
+            <a:schemeClr val="accent1"/>
+          </a:effectRef>
+          <a:fontRef idx="minor">
+            <a:schemeClr val="lt1"/>
+          </a:fontRef>
+        </p:style>
+        <p:txBody>
+          <a:bodyPr rtlCol="0" anchor="ctr"/>
+          <a:lstStyle/>
+          <a:p>
+            <a:pPr algn="ctr"/>
+            <a:endParaRPr lang="LID4096"/>
+          </a:p>
+        </p:txBody>
+      </p:sp>
+      <p:sp>
+        <p:nvSpPr>
+          <p:cNvPr id="27" name="TextBox 26">
+            <a:extLst>
+              <a:ext uri="{FF2B5EF4-FFF2-40B4-BE49-F238E27FC236}">
+                <a16:creationId xmlns:a16="http://schemas.microsoft.com/office/drawing/2014/main" id="{773F74AA-542D-5BB0-5C2C-A05B0DEBD28B}"/>
+              </a:ext>
+            </a:extLst>
+          </p:cNvPr>
+          <p:cNvSpPr txBox="1"/>
+          <p:nvPr/>
+        </p:nvSpPr>
+        <p:spPr>
+          <a:xfrm>
+            <a:off x="6235873" y="2163074"/>
+            <a:ext cx="922047" cy="253916"/>
+          </a:xfrm>
+          <a:prstGeom prst="rect">
+            <a:avLst/>
+          </a:prstGeom>
+          <a:noFill/>
+        </p:spPr>
+        <p:txBody>
+          <a:bodyPr wrap="none" rtlCol="0">
+            <a:spAutoFit/>
+          </a:bodyPr>
+          <a:lstStyle/>
+          <a:p>
+            <a:r>
+              <a:rPr lang="en-GB" sz="1050">
+                <a:latin typeface="Consolas" panose="020B0609020204030204" pitchFamily="49" charset="0"/>
+              </a:rPr>
+              <a:t>0x2000FFF8</a:t>
+            </a:r>
+            <a:endParaRPr lang="LID4096" sz="1050">
+              <a:latin typeface="Consolas" panose="020B0609020204030204" pitchFamily="49" charset="0"/>
+            </a:endParaRPr>
+          </a:p>
+        </p:txBody>
+      </p:sp>
+      <p:sp>
+        <p:nvSpPr>
+          <p:cNvPr id="28" name="Rectangle 27">
+            <a:extLst>
+              <a:ext uri="{FF2B5EF4-FFF2-40B4-BE49-F238E27FC236}">
+                <a16:creationId xmlns:a16="http://schemas.microsoft.com/office/drawing/2014/main" id="{6C3EA220-8D9F-B2B7-0714-B3EEB8E27D7C}"/>
+              </a:ext>
+            </a:extLst>
+          </p:cNvPr>
+          <p:cNvSpPr/>
+          <p:nvPr/>
+        </p:nvSpPr>
+        <p:spPr>
+          <a:xfrm>
+            <a:off x="4979381" y="1941848"/>
+            <a:ext cx="1256492" cy="231131"/>
+          </a:xfrm>
+          <a:prstGeom prst="rect">
+            <a:avLst/>
+          </a:prstGeom>
+          <a:noFill/>
+        </p:spPr>
+        <p:style>
+          <a:lnRef idx="2">
+            <a:schemeClr val="accent1">
+              <a:shade val="15000"/>
+            </a:schemeClr>
+          </a:lnRef>
+          <a:fillRef idx="1">
+            <a:schemeClr val="accent1"/>
+          </a:fillRef>
+          <a:effectRef idx="0">
+            <a:schemeClr val="accent1"/>
+          </a:effectRef>
+          <a:fontRef idx="minor">
+            <a:schemeClr val="lt1"/>
+          </a:fontRef>
+        </p:style>
+        <p:txBody>
+          <a:bodyPr rtlCol="0" anchor="ctr"/>
+          <a:lstStyle/>
+          <a:p>
+            <a:pPr algn="ctr"/>
+            <a:endParaRPr lang="LID4096"/>
+          </a:p>
+        </p:txBody>
+      </p:sp>
+      <p:sp>
+        <p:nvSpPr>
+          <p:cNvPr id="29" name="TextBox 28">
+            <a:extLst>
+              <a:ext uri="{FF2B5EF4-FFF2-40B4-BE49-F238E27FC236}">
+                <a16:creationId xmlns:a16="http://schemas.microsoft.com/office/drawing/2014/main" id="{C3C19A3D-5D9D-9AA4-9614-3D454ACDD7E5}"/>
+              </a:ext>
+            </a:extLst>
+          </p:cNvPr>
+          <p:cNvSpPr txBox="1"/>
+          <p:nvPr/>
+        </p:nvSpPr>
+        <p:spPr>
+          <a:xfrm>
+            <a:off x="6235873" y="1930876"/>
+            <a:ext cx="922047" cy="253916"/>
+          </a:xfrm>
+          <a:prstGeom prst="rect">
+            <a:avLst/>
+          </a:prstGeom>
+          <a:noFill/>
+        </p:spPr>
+        <p:txBody>
+          <a:bodyPr wrap="none" rtlCol="0">
+            <a:spAutoFit/>
+          </a:bodyPr>
+          <a:lstStyle/>
+          <a:p>
+            <a:r>
+              <a:rPr lang="en-GB" sz="1050">
+                <a:latin typeface="Consolas" panose="020B0609020204030204" pitchFamily="49" charset="0"/>
+              </a:rPr>
+              <a:t>0x2000FFFC</a:t>
+            </a:r>
+            <a:endParaRPr lang="LID4096" sz="1050">
+              <a:latin typeface="Consolas" panose="020B0609020204030204" pitchFamily="49" charset="0"/>
+            </a:endParaRPr>
+          </a:p>
+        </p:txBody>
+      </p:sp>
+      <p:sp>
+        <p:nvSpPr>
+          <p:cNvPr id="31" name="Rectangle 30">
+            <a:extLst>
+              <a:ext uri="{FF2B5EF4-FFF2-40B4-BE49-F238E27FC236}">
+                <a16:creationId xmlns:a16="http://schemas.microsoft.com/office/drawing/2014/main" id="{001B17A7-4644-EA91-1F6B-0BD828AF6F7E}"/>
+              </a:ext>
+            </a:extLst>
+          </p:cNvPr>
+          <p:cNvSpPr/>
+          <p:nvPr/>
+        </p:nvSpPr>
+        <p:spPr>
+          <a:xfrm>
+            <a:off x="4979381" y="2625028"/>
+            <a:ext cx="1256492" cy="231131"/>
+          </a:xfrm>
+          <a:prstGeom prst="rect">
+            <a:avLst/>
+          </a:prstGeom>
+          <a:solidFill>
+            <a:schemeClr val="bg1">
+              <a:lumMod val="85000"/>
+            </a:schemeClr>
+          </a:solidFill>
+        </p:spPr>
+        <p:style>
+          <a:lnRef idx="2">
+            <a:schemeClr val="accent1">
+              <a:shade val="15000"/>
+            </a:schemeClr>
+          </a:lnRef>
+          <a:fillRef idx="1">
+            <a:schemeClr val="accent1"/>
+          </a:fillRef>
+          <a:effectRef idx="0">
+            <a:schemeClr val="accent1"/>
+          </a:effectRef>
+          <a:fontRef idx="minor">
+            <a:schemeClr val="lt1"/>
+          </a:fontRef>
+        </p:style>
+        <p:txBody>
+          <a:bodyPr rtlCol="0" anchor="ctr"/>
+          <a:lstStyle/>
+          <a:p>
+            <a:pPr algn="ctr"/>
+            <a:endParaRPr lang="LID4096"/>
+          </a:p>
+        </p:txBody>
+      </p:sp>
+      <p:sp>
+        <p:nvSpPr>
+          <p:cNvPr id="32" name="TextBox 31">
+            <a:extLst>
+              <a:ext uri="{FF2B5EF4-FFF2-40B4-BE49-F238E27FC236}">
+                <a16:creationId xmlns:a16="http://schemas.microsoft.com/office/drawing/2014/main" id="{42E3C354-F802-1329-3E7F-65BF4DD390CA}"/>
+              </a:ext>
+            </a:extLst>
+          </p:cNvPr>
+          <p:cNvSpPr txBox="1"/>
+          <p:nvPr/>
+        </p:nvSpPr>
+        <p:spPr>
+          <a:xfrm>
+            <a:off x="6235873" y="2621829"/>
+            <a:ext cx="922047" cy="253916"/>
+          </a:xfrm>
+          <a:prstGeom prst="rect">
+            <a:avLst/>
+          </a:prstGeom>
+          <a:noFill/>
+        </p:spPr>
+        <p:txBody>
+          <a:bodyPr wrap="none" rtlCol="0">
+            <a:spAutoFit/>
+          </a:bodyPr>
+          <a:lstStyle/>
+          <a:p>
+            <a:r>
+              <a:rPr lang="en-GB" sz="1050">
+                <a:latin typeface="Consolas" panose="020B0609020204030204" pitchFamily="49" charset="0"/>
+              </a:rPr>
+              <a:t>0x2000FFF0</a:t>
+            </a:r>
+            <a:endParaRPr lang="LID4096" sz="1050">
+              <a:latin typeface="Consolas" panose="020B0609020204030204" pitchFamily="49" charset="0"/>
+            </a:endParaRPr>
+          </a:p>
+        </p:txBody>
+      </p:sp>
+      <p:sp>
+        <p:nvSpPr>
+          <p:cNvPr id="33" name="Rectangle 32">
+            <a:extLst>
+              <a:ext uri="{FF2B5EF4-FFF2-40B4-BE49-F238E27FC236}">
+                <a16:creationId xmlns:a16="http://schemas.microsoft.com/office/drawing/2014/main" id="{D29BB9E1-DC40-DB75-BDCE-1049FB1FE1BB}"/>
+              </a:ext>
+            </a:extLst>
+          </p:cNvPr>
+          <p:cNvSpPr/>
+          <p:nvPr/>
+        </p:nvSpPr>
+        <p:spPr>
+          <a:xfrm>
+            <a:off x="4979381" y="2400603"/>
+            <a:ext cx="1256492" cy="231131"/>
+          </a:xfrm>
+          <a:prstGeom prst="rect">
+            <a:avLst/>
+          </a:prstGeom>
+          <a:noFill/>
+        </p:spPr>
+        <p:style>
+          <a:lnRef idx="2">
+            <a:schemeClr val="accent1">
+              <a:shade val="15000"/>
+            </a:schemeClr>
+          </a:lnRef>
+          <a:fillRef idx="1">
+            <a:schemeClr val="accent1"/>
+          </a:fillRef>
+          <a:effectRef idx="0">
+            <a:schemeClr val="accent1"/>
+          </a:effectRef>
+          <a:fontRef idx="minor">
+            <a:schemeClr val="lt1"/>
+          </a:fontRef>
+        </p:style>
+        <p:txBody>
+          <a:bodyPr rtlCol="0" anchor="ctr"/>
+          <a:lstStyle/>
+          <a:p>
+            <a:pPr algn="ctr"/>
+            <a:endParaRPr lang="LID4096"/>
+          </a:p>
+        </p:txBody>
+      </p:sp>
+      <p:sp>
+        <p:nvSpPr>
+          <p:cNvPr id="34" name="TextBox 33">
+            <a:extLst>
+              <a:ext uri="{FF2B5EF4-FFF2-40B4-BE49-F238E27FC236}">
+                <a16:creationId xmlns:a16="http://schemas.microsoft.com/office/drawing/2014/main" id="{41ED3A92-7928-B50D-B9C9-8AF9968DD36F}"/>
+              </a:ext>
+            </a:extLst>
+          </p:cNvPr>
+          <p:cNvSpPr txBox="1"/>
+          <p:nvPr/>
+        </p:nvSpPr>
+        <p:spPr>
+          <a:xfrm>
+            <a:off x="6235873" y="2389631"/>
+            <a:ext cx="922047" cy="253916"/>
+          </a:xfrm>
+          <a:prstGeom prst="rect">
+            <a:avLst/>
+          </a:prstGeom>
+          <a:noFill/>
+        </p:spPr>
+        <p:txBody>
+          <a:bodyPr wrap="none" rtlCol="0">
+            <a:spAutoFit/>
+          </a:bodyPr>
+          <a:lstStyle/>
+          <a:p>
+            <a:r>
+              <a:rPr lang="en-GB" sz="1050">
+                <a:latin typeface="Consolas" panose="020B0609020204030204" pitchFamily="49" charset="0"/>
+              </a:rPr>
+              <a:t>0x2000FFF4</a:t>
+            </a:r>
+            <a:endParaRPr lang="LID4096" sz="1050">
+              <a:latin typeface="Consolas" panose="020B0609020204030204" pitchFamily="49" charset="0"/>
+            </a:endParaRPr>
+          </a:p>
+        </p:txBody>
+      </p:sp>
+      <p:sp>
+        <p:nvSpPr>
+          <p:cNvPr id="35" name="TextBox 34">
+            <a:extLst>
+              <a:ext uri="{FF2B5EF4-FFF2-40B4-BE49-F238E27FC236}">
+                <a16:creationId xmlns:a16="http://schemas.microsoft.com/office/drawing/2014/main" id="{61BE9703-9287-53AB-B9E7-8C2089F8529F}"/>
+              </a:ext>
+            </a:extLst>
+          </p:cNvPr>
+          <p:cNvSpPr txBox="1"/>
+          <p:nvPr/>
+        </p:nvSpPr>
+        <p:spPr>
+          <a:xfrm>
+            <a:off x="6235873" y="999342"/>
+            <a:ext cx="1290738" cy="492443"/>
+          </a:xfrm>
+          <a:prstGeom prst="rect">
+            <a:avLst/>
+          </a:prstGeom>
+          <a:noFill/>
+        </p:spPr>
+        <p:txBody>
+          <a:bodyPr wrap="none" rtlCol="0">
+            <a:spAutoFit/>
+          </a:bodyPr>
+          <a:lstStyle/>
+          <a:p>
+            <a:r>
+              <a:rPr lang="en-GB" sz="1050" b="1">
+                <a:latin typeface="Consolas" panose="020B0609020204030204" pitchFamily="49" charset="0"/>
+              </a:rPr>
+              <a:t>sp</a:t>
+            </a:r>
+            <a:r>
+              <a:rPr lang="en-GB" sz="1050">
+                <a:latin typeface="Consolas" panose="020B0609020204030204" pitchFamily="49" charset="0"/>
+              </a:rPr>
+              <a:t> = 0x2000FFF4</a:t>
+            </a:r>
+          </a:p>
+          <a:p>
+            <a:pPr algn="ctr"/>
+            <a:r>
+              <a:rPr lang="en-GB" sz="500">
+                <a:latin typeface="Consolas" panose="020B0609020204030204" pitchFamily="49" charset="0"/>
+              </a:rPr>
+              <a:t>= &lt;top of stack&gt;</a:t>
+            </a:r>
+          </a:p>
+          <a:p>
+            <a:endParaRPr lang="LID4096" sz="1050">
+              <a:latin typeface="Consolas" panose="020B0609020204030204" pitchFamily="49" charset="0"/>
+            </a:endParaRPr>
+          </a:p>
+        </p:txBody>
+      </p:sp>
+      <p:sp>
+        <p:nvSpPr>
+          <p:cNvPr id="36" name="Arrow: Bent 35">
+            <a:extLst>
+              <a:ext uri="{FF2B5EF4-FFF2-40B4-BE49-F238E27FC236}">
+                <a16:creationId xmlns:a16="http://schemas.microsoft.com/office/drawing/2014/main" id="{2D52C49E-6190-ADF6-6E72-94DD2B65BF4A}"/>
+              </a:ext>
+            </a:extLst>
+          </p:cNvPr>
+          <p:cNvSpPr/>
+          <p:nvPr/>
+        </p:nvSpPr>
+        <p:spPr>
+          <a:xfrm flipH="1" flipV="1">
+            <a:off x="7125222" y="1287072"/>
+            <a:ext cx="304800" cy="1286641"/>
+          </a:xfrm>
+          <a:prstGeom prst="bentArrow">
+            <a:avLst/>
+          </a:prstGeom>
+          <a:solidFill>
+            <a:schemeClr val="bg1">
+              <a:lumMod val="85000"/>
+            </a:schemeClr>
+          </a:solidFill>
+          <a:ln w="12700">
+            <a:solidFill>
+              <a:schemeClr val="tx1"/>
+            </a:solidFill>
+          </a:ln>
+        </p:spPr>
+        <p:style>
+          <a:lnRef idx="2">
+            <a:schemeClr val="accent1">
+              <a:shade val="15000"/>
+            </a:schemeClr>
+          </a:lnRef>
+          <a:fillRef idx="1">
+            <a:schemeClr val="accent1"/>
+          </a:fillRef>
+          <a:effectRef idx="0">
+            <a:schemeClr val="accent1"/>
+          </a:effectRef>
+          <a:fontRef idx="minor">
+            <a:schemeClr val="lt1"/>
+          </a:fontRef>
+        </p:style>
+        <p:txBody>
+          <a:bodyPr rtlCol="0" anchor="ctr"/>
+          <a:lstStyle/>
+          <a:p>
+            <a:pPr algn="ctr"/>
+            <a:endParaRPr lang="LID4096">
+              <a:solidFill>
+                <a:schemeClr val="tx1"/>
+              </a:solidFill>
+            </a:endParaRPr>
+          </a:p>
+        </p:txBody>
+      </p:sp>
+      <p:sp>
+        <p:nvSpPr>
+          <p:cNvPr id="37" name="Rectangle 36">
+            <a:extLst>
+              <a:ext uri="{FF2B5EF4-FFF2-40B4-BE49-F238E27FC236}">
+                <a16:creationId xmlns:a16="http://schemas.microsoft.com/office/drawing/2014/main" id="{949B5D2F-3718-77C2-8EEC-F290B105FB44}"/>
+              </a:ext>
+            </a:extLst>
+          </p:cNvPr>
+          <p:cNvSpPr/>
+          <p:nvPr/>
+        </p:nvSpPr>
+        <p:spPr>
+          <a:xfrm>
+            <a:off x="8007747" y="1463507"/>
+            <a:ext cx="1256492" cy="231131"/>
+          </a:xfrm>
+          <a:prstGeom prst="rect">
+            <a:avLst/>
+          </a:prstGeom>
+          <a:noFill/>
+          <a:ln>
+            <a:solidFill>
+              <a:schemeClr val="bg1">
+                <a:lumMod val="65000"/>
+              </a:schemeClr>
+            </a:solidFill>
+          </a:ln>
+        </p:spPr>
+        <p:style>
+          <a:lnRef idx="2">
+            <a:schemeClr val="accent1">
+              <a:shade val="15000"/>
+            </a:schemeClr>
+          </a:lnRef>
+          <a:fillRef idx="1">
+            <a:schemeClr val="accent1"/>
+          </a:fillRef>
+          <a:effectRef idx="0">
+            <a:schemeClr val="accent1"/>
+          </a:effectRef>
+          <a:fontRef idx="minor">
+            <a:schemeClr val="lt1"/>
+          </a:fontRef>
+        </p:style>
+        <p:txBody>
+          <a:bodyPr rtlCol="0" anchor="ctr"/>
+          <a:lstStyle/>
+          <a:p>
+            <a:pPr algn="ctr"/>
+            <a:endParaRPr lang="LID4096"/>
+          </a:p>
+        </p:txBody>
+      </p:sp>
+      <p:sp>
+        <p:nvSpPr>
+          <p:cNvPr id="38" name="Rectangle 37">
+            <a:extLst>
+              <a:ext uri="{FF2B5EF4-FFF2-40B4-BE49-F238E27FC236}">
+                <a16:creationId xmlns:a16="http://schemas.microsoft.com/office/drawing/2014/main" id="{1954C094-1447-94B6-08D3-F693304D7543}"/>
+              </a:ext>
+            </a:extLst>
+          </p:cNvPr>
+          <p:cNvSpPr/>
+          <p:nvPr/>
+        </p:nvSpPr>
+        <p:spPr>
+          <a:xfrm>
+            <a:off x="8007747" y="1687932"/>
+            <a:ext cx="1256492" cy="231131"/>
+          </a:xfrm>
+          <a:prstGeom prst="rect">
+            <a:avLst/>
+          </a:prstGeom>
+          <a:noFill/>
+          <a:ln>
+            <a:solidFill>
+              <a:schemeClr val="bg1">
+                <a:lumMod val="65000"/>
+              </a:schemeClr>
+            </a:solidFill>
+          </a:ln>
+        </p:spPr>
+        <p:style>
+          <a:lnRef idx="2">
+            <a:schemeClr val="accent1">
+              <a:shade val="15000"/>
+            </a:schemeClr>
+          </a:lnRef>
+          <a:fillRef idx="1">
+            <a:schemeClr val="accent1"/>
+          </a:fillRef>
+          <a:effectRef idx="0">
+            <a:schemeClr val="accent1"/>
+          </a:effectRef>
+          <a:fontRef idx="minor">
+            <a:schemeClr val="lt1"/>
+          </a:fontRef>
+        </p:style>
+        <p:txBody>
+          <a:bodyPr rtlCol="0" anchor="ctr"/>
+          <a:lstStyle/>
+          <a:p>
+            <a:pPr algn="ctr"/>
+            <a:endParaRPr lang="LID4096"/>
+          </a:p>
+        </p:txBody>
+      </p:sp>
+      <p:sp>
+        <p:nvSpPr>
+          <p:cNvPr id="39" name="TextBox 38">
+            <a:extLst>
+              <a:ext uri="{FF2B5EF4-FFF2-40B4-BE49-F238E27FC236}">
+                <a16:creationId xmlns:a16="http://schemas.microsoft.com/office/drawing/2014/main" id="{E0E33384-FB25-6391-EDF2-88AB15CBA9C0}"/>
+              </a:ext>
+            </a:extLst>
+          </p:cNvPr>
+          <p:cNvSpPr txBox="1"/>
+          <p:nvPr/>
+        </p:nvSpPr>
+        <p:spPr>
+          <a:xfrm>
+            <a:off x="9264239" y="1684733"/>
+            <a:ext cx="954107" cy="261610"/>
+          </a:xfrm>
+          <a:prstGeom prst="rect">
+            <a:avLst/>
+          </a:prstGeom>
+          <a:noFill/>
+        </p:spPr>
+        <p:txBody>
+          <a:bodyPr wrap="none" rtlCol="0">
+            <a:spAutoFit/>
+          </a:bodyPr>
+          <a:lstStyle/>
+          <a:p>
+            <a:r>
+              <a:rPr lang="en-GB" sz="1050">
+                <a:latin typeface="Consolas" panose="020B0609020204030204" pitchFamily="49" charset="0"/>
+              </a:rPr>
+              <a:t>0x20010000</a:t>
+            </a:r>
+            <a:endParaRPr lang="LID4096" sz="1050">
+              <a:latin typeface="Consolas" panose="020B0609020204030204" pitchFamily="49" charset="0"/>
+            </a:endParaRPr>
+          </a:p>
+        </p:txBody>
+      </p:sp>
+      <p:sp>
+        <p:nvSpPr>
+          <p:cNvPr id="40" name="TextBox 39">
+            <a:extLst>
+              <a:ext uri="{FF2B5EF4-FFF2-40B4-BE49-F238E27FC236}">
+                <a16:creationId xmlns:a16="http://schemas.microsoft.com/office/drawing/2014/main" id="{8DDD5514-C71D-59C2-0BCA-D3B1E7ECAC96}"/>
+              </a:ext>
+            </a:extLst>
+          </p:cNvPr>
+          <p:cNvSpPr txBox="1"/>
+          <p:nvPr/>
+        </p:nvSpPr>
+        <p:spPr>
+          <a:xfrm>
+            <a:off x="9264239" y="1452535"/>
+            <a:ext cx="922047" cy="253916"/>
+          </a:xfrm>
+          <a:prstGeom prst="rect">
+            <a:avLst/>
+          </a:prstGeom>
+          <a:noFill/>
+        </p:spPr>
+        <p:txBody>
+          <a:bodyPr wrap="none" rtlCol="0">
+            <a:spAutoFit/>
+          </a:bodyPr>
+          <a:lstStyle/>
+          <a:p>
+            <a:r>
+              <a:rPr lang="en-GB" sz="1050">
+                <a:solidFill>
+                  <a:schemeClr val="bg1">
+                    <a:lumMod val="65000"/>
+                  </a:schemeClr>
+                </a:solidFill>
+                <a:latin typeface="Consolas" panose="020B0609020204030204" pitchFamily="49" charset="0"/>
+              </a:rPr>
+              <a:t>0x20010004</a:t>
+            </a:r>
+            <a:endParaRPr lang="LID4096" sz="1050">
+              <a:solidFill>
+                <a:schemeClr val="bg1">
+                  <a:lumMod val="65000"/>
+                </a:schemeClr>
+              </a:solidFill>
+              <a:latin typeface="Consolas" panose="020B0609020204030204" pitchFamily="49" charset="0"/>
+            </a:endParaRPr>
+          </a:p>
+        </p:txBody>
+      </p:sp>
+      <p:grpSp>
+        <p:nvGrpSpPr>
+          <p:cNvPr id="41" name="Group 40">
+            <a:extLst>
+              <a:ext uri="{FF2B5EF4-FFF2-40B4-BE49-F238E27FC236}">
+                <a16:creationId xmlns:a16="http://schemas.microsoft.com/office/drawing/2014/main" id="{6C278E5A-1471-FF1D-F3AB-08384BD5A29F}"/>
+              </a:ext>
+            </a:extLst>
+          </p:cNvPr>
+          <p:cNvGrpSpPr/>
+          <p:nvPr/>
+        </p:nvGrpSpPr>
+        <p:grpSpPr>
+          <a:xfrm>
+            <a:off x="8007747" y="2143488"/>
+            <a:ext cx="2178539" cy="253916"/>
+            <a:chOff x="1916769" y="1723905"/>
+            <a:chExt cx="2178539" cy="253916"/>
+          </a:xfrm>
+        </p:grpSpPr>
+        <p:sp>
+          <p:nvSpPr>
+            <p:cNvPr id="42" name="Rectangle 41">
+              <a:extLst>
+                <a:ext uri="{FF2B5EF4-FFF2-40B4-BE49-F238E27FC236}">
+                  <a16:creationId xmlns:a16="http://schemas.microsoft.com/office/drawing/2014/main" id="{DC864059-6715-5D2C-6B26-6A817F75E531}"/>
+                </a:ext>
+              </a:extLst>
+            </p:cNvPr>
+            <p:cNvSpPr/>
+            <p:nvPr/>
+          </p:nvSpPr>
+          <p:spPr>
+            <a:xfrm>
+              <a:off x="1916769" y="1727104"/>
+              <a:ext cx="1256492" cy="231131"/>
+            </a:xfrm>
+            <a:prstGeom prst="rect">
+              <a:avLst/>
+            </a:prstGeom>
+            <a:noFill/>
+          </p:spPr>
+          <p:style>
+            <a:lnRef idx="2">
+              <a:schemeClr val="accent1">
+                <a:shade val="15000"/>
+              </a:schemeClr>
+            </a:lnRef>
+            <a:fillRef idx="1">
+              <a:schemeClr val="accent1"/>
+            </a:fillRef>
+            <a:effectRef idx="0">
+              <a:schemeClr val="accent1"/>
+            </a:effectRef>
+            <a:fontRef idx="minor">
+              <a:schemeClr val="lt1"/>
+            </a:fontRef>
+          </p:style>
+          <p:txBody>
+            <a:bodyPr rtlCol="0" anchor="ctr"/>
+            <a:lstStyle/>
+            <a:p>
+              <a:pPr algn="ctr"/>
+              <a:endParaRPr lang="LID4096"/>
+            </a:p>
+          </p:txBody>
+        </p:sp>
+        <p:sp>
+          <p:nvSpPr>
+            <p:cNvPr id="43" name="TextBox 42">
+              <a:extLst>
+                <a:ext uri="{FF2B5EF4-FFF2-40B4-BE49-F238E27FC236}">
+                  <a16:creationId xmlns:a16="http://schemas.microsoft.com/office/drawing/2014/main" id="{6FD87A6B-B97F-FC24-2E63-542129847593}"/>
+                </a:ext>
+              </a:extLst>
+            </p:cNvPr>
+            <p:cNvSpPr txBox="1"/>
+            <p:nvPr/>
+          </p:nvSpPr>
+          <p:spPr>
+            <a:xfrm>
+              <a:off x="3173261" y="1723905"/>
+              <a:ext cx="922047" cy="253916"/>
+            </a:xfrm>
+            <a:prstGeom prst="rect">
+              <a:avLst/>
+            </a:prstGeom>
+            <a:noFill/>
+          </p:spPr>
+          <p:txBody>
+            <a:bodyPr wrap="none" rtlCol="0">
+              <a:spAutoFit/>
+            </a:bodyPr>
+            <a:lstStyle/>
+            <a:p>
+              <a:r>
+                <a:rPr lang="en-GB" sz="1050">
+                  <a:latin typeface="Consolas" panose="020B0609020204030204" pitchFamily="49" charset="0"/>
+                </a:rPr>
+                <a:t>0x2000FFF8</a:t>
+              </a:r>
+              <a:endParaRPr lang="LID4096" sz="1050">
+                <a:latin typeface="Consolas" panose="020B0609020204030204" pitchFamily="49" charset="0"/>
+              </a:endParaRPr>
+            </a:p>
+          </p:txBody>
+        </p:sp>
+      </p:grpSp>
+      <p:sp>
+        <p:nvSpPr>
+          <p:cNvPr id="44" name="Rectangle 43">
+            <a:extLst>
+              <a:ext uri="{FF2B5EF4-FFF2-40B4-BE49-F238E27FC236}">
+                <a16:creationId xmlns:a16="http://schemas.microsoft.com/office/drawing/2014/main" id="{0528A562-DF4C-DDBB-3896-FF72D7AE9C66}"/>
+              </a:ext>
+            </a:extLst>
+          </p:cNvPr>
+          <p:cNvSpPr/>
+          <p:nvPr/>
+        </p:nvSpPr>
+        <p:spPr>
+          <a:xfrm>
+            <a:off x="8007747" y="1922262"/>
+            <a:ext cx="1256492" cy="231131"/>
+          </a:xfrm>
+          <a:prstGeom prst="rect">
+            <a:avLst/>
+          </a:prstGeom>
+          <a:noFill/>
+        </p:spPr>
+        <p:style>
+          <a:lnRef idx="2">
+            <a:schemeClr val="accent1">
+              <a:shade val="15000"/>
+            </a:schemeClr>
+          </a:lnRef>
+          <a:fillRef idx="1">
+            <a:schemeClr val="accent1"/>
+          </a:fillRef>
+          <a:effectRef idx="0">
+            <a:schemeClr val="accent1"/>
+          </a:effectRef>
+          <a:fontRef idx="minor">
+            <a:schemeClr val="lt1"/>
+          </a:fontRef>
+        </p:style>
+        <p:txBody>
+          <a:bodyPr rtlCol="0" anchor="ctr"/>
+          <a:lstStyle/>
+          <a:p>
+            <a:pPr algn="ctr"/>
+            <a:endParaRPr lang="LID4096"/>
+          </a:p>
+        </p:txBody>
+      </p:sp>
+      <p:sp>
+        <p:nvSpPr>
+          <p:cNvPr id="45" name="TextBox 44">
+            <a:extLst>
+              <a:ext uri="{FF2B5EF4-FFF2-40B4-BE49-F238E27FC236}">
+                <a16:creationId xmlns:a16="http://schemas.microsoft.com/office/drawing/2014/main" id="{DC386745-66A8-57CA-45E9-3E868CCF4956}"/>
+              </a:ext>
+            </a:extLst>
+          </p:cNvPr>
+          <p:cNvSpPr txBox="1"/>
+          <p:nvPr/>
+        </p:nvSpPr>
+        <p:spPr>
+          <a:xfrm>
+            <a:off x="9264239" y="1911290"/>
+            <a:ext cx="922047" cy="253916"/>
+          </a:xfrm>
+          <a:prstGeom prst="rect">
+            <a:avLst/>
+          </a:prstGeom>
+          <a:noFill/>
+        </p:spPr>
+        <p:txBody>
+          <a:bodyPr wrap="none" rtlCol="0">
+            <a:spAutoFit/>
+          </a:bodyPr>
+          <a:lstStyle/>
+          <a:p>
+            <a:r>
+              <a:rPr lang="en-GB" sz="1050">
+                <a:latin typeface="Consolas" panose="020B0609020204030204" pitchFamily="49" charset="0"/>
+              </a:rPr>
+              <a:t>0x2000FFFC</a:t>
+            </a:r>
+            <a:endParaRPr lang="LID4096" sz="1050">
+              <a:latin typeface="Consolas" panose="020B0609020204030204" pitchFamily="49" charset="0"/>
+            </a:endParaRPr>
+          </a:p>
+        </p:txBody>
+      </p:sp>
+      <p:grpSp>
+        <p:nvGrpSpPr>
+          <p:cNvPr id="46" name="Group 45">
+            <a:extLst>
+              <a:ext uri="{FF2B5EF4-FFF2-40B4-BE49-F238E27FC236}">
+                <a16:creationId xmlns:a16="http://schemas.microsoft.com/office/drawing/2014/main" id="{2E9C53EF-F98C-D3B9-79FF-ECE721C491C0}"/>
+              </a:ext>
+            </a:extLst>
+          </p:cNvPr>
+          <p:cNvGrpSpPr/>
+          <p:nvPr/>
+        </p:nvGrpSpPr>
+        <p:grpSpPr>
+          <a:xfrm>
+            <a:off x="8007747" y="2602243"/>
+            <a:ext cx="2178539" cy="253916"/>
+            <a:chOff x="1916769" y="1723905"/>
+            <a:chExt cx="2178539" cy="253916"/>
+          </a:xfrm>
+        </p:grpSpPr>
+        <p:sp>
+          <p:nvSpPr>
+            <p:cNvPr id="47" name="Rectangle 46">
+              <a:extLst>
+                <a:ext uri="{FF2B5EF4-FFF2-40B4-BE49-F238E27FC236}">
+                  <a16:creationId xmlns:a16="http://schemas.microsoft.com/office/drawing/2014/main" id="{EFB4F694-A6F3-06CB-CA3C-8DD78C40E9D9}"/>
+                </a:ext>
+              </a:extLst>
+            </p:cNvPr>
+            <p:cNvSpPr/>
+            <p:nvPr/>
+          </p:nvSpPr>
+          <p:spPr>
+            <a:xfrm>
+              <a:off x="1916769" y="1727104"/>
+              <a:ext cx="1256492" cy="231131"/>
+            </a:xfrm>
+            <a:prstGeom prst="rect">
+              <a:avLst/>
+            </a:prstGeom>
+            <a:solidFill>
+              <a:schemeClr val="bg1">
+                <a:lumMod val="85000"/>
+              </a:schemeClr>
+            </a:solidFill>
+          </p:spPr>
+          <p:style>
+            <a:lnRef idx="2">
+              <a:schemeClr val="accent1">
+                <a:shade val="15000"/>
+              </a:schemeClr>
+            </a:lnRef>
+            <a:fillRef idx="1">
+              <a:schemeClr val="accent1"/>
+            </a:fillRef>
+            <a:effectRef idx="0">
+              <a:schemeClr val="accent1"/>
+            </a:effectRef>
+            <a:fontRef idx="minor">
+              <a:schemeClr val="lt1"/>
+            </a:fontRef>
+          </p:style>
+          <p:txBody>
+            <a:bodyPr rtlCol="0" anchor="ctr"/>
+            <a:lstStyle/>
+            <a:p>
+              <a:pPr algn="ctr"/>
+              <a:endParaRPr lang="LID4096"/>
+            </a:p>
+          </p:txBody>
+        </p:sp>
+        <p:sp>
+          <p:nvSpPr>
+            <p:cNvPr id="48" name="TextBox 47">
+              <a:extLst>
+                <a:ext uri="{FF2B5EF4-FFF2-40B4-BE49-F238E27FC236}">
+                  <a16:creationId xmlns:a16="http://schemas.microsoft.com/office/drawing/2014/main" id="{1B909B8A-649A-76EF-284B-B3F9E5936C06}"/>
+                </a:ext>
+              </a:extLst>
+            </p:cNvPr>
+            <p:cNvSpPr txBox="1"/>
+            <p:nvPr/>
+          </p:nvSpPr>
+          <p:spPr>
+            <a:xfrm>
+              <a:off x="3173261" y="1723905"/>
+              <a:ext cx="922047" cy="253916"/>
+            </a:xfrm>
+            <a:prstGeom prst="rect">
+              <a:avLst/>
+            </a:prstGeom>
+            <a:noFill/>
+          </p:spPr>
+          <p:txBody>
+            <a:bodyPr wrap="none" rtlCol="0">
+              <a:spAutoFit/>
+            </a:bodyPr>
+            <a:lstStyle/>
+            <a:p>
+              <a:r>
+                <a:rPr lang="en-GB" sz="1050">
+                  <a:latin typeface="Consolas" panose="020B0609020204030204" pitchFamily="49" charset="0"/>
+                </a:rPr>
+                <a:t>0x2000FFF0</a:t>
+              </a:r>
+              <a:endParaRPr lang="LID4096" sz="1050">
+                <a:latin typeface="Consolas" panose="020B0609020204030204" pitchFamily="49" charset="0"/>
+              </a:endParaRPr>
+            </a:p>
+          </p:txBody>
+        </p:sp>
+      </p:grpSp>
+      <p:sp>
+        <p:nvSpPr>
+          <p:cNvPr id="49" name="Rectangle 48">
+            <a:extLst>
+              <a:ext uri="{FF2B5EF4-FFF2-40B4-BE49-F238E27FC236}">
+                <a16:creationId xmlns:a16="http://schemas.microsoft.com/office/drawing/2014/main" id="{6DE37775-DBC6-AAED-4DD3-831B98FAA498}"/>
+              </a:ext>
+            </a:extLst>
+          </p:cNvPr>
+          <p:cNvSpPr/>
+          <p:nvPr/>
+        </p:nvSpPr>
+        <p:spPr>
+          <a:xfrm>
+            <a:off x="8007747" y="2381017"/>
+            <a:ext cx="1256492" cy="231131"/>
+          </a:xfrm>
+          <a:prstGeom prst="rect">
+            <a:avLst/>
+          </a:prstGeom>
+          <a:noFill/>
+        </p:spPr>
+        <p:style>
+          <a:lnRef idx="2">
+            <a:schemeClr val="accent1">
+              <a:shade val="15000"/>
+            </a:schemeClr>
+          </a:lnRef>
+          <a:fillRef idx="1">
+            <a:schemeClr val="accent1"/>
+          </a:fillRef>
+          <a:effectRef idx="0">
+            <a:schemeClr val="accent1"/>
+          </a:effectRef>
+          <a:fontRef idx="minor">
+            <a:schemeClr val="lt1"/>
+          </a:fontRef>
+        </p:style>
+        <p:txBody>
+          <a:bodyPr rtlCol="0" anchor="ctr"/>
+          <a:lstStyle/>
+          <a:p>
+            <a:pPr algn="ctr"/>
+            <a:endParaRPr lang="LID4096"/>
+          </a:p>
+        </p:txBody>
+      </p:sp>
+      <p:sp>
+        <p:nvSpPr>
+          <p:cNvPr id="50" name="TextBox 49">
+            <a:extLst>
+              <a:ext uri="{FF2B5EF4-FFF2-40B4-BE49-F238E27FC236}">
+                <a16:creationId xmlns:a16="http://schemas.microsoft.com/office/drawing/2014/main" id="{D97835CE-61DF-F963-4B87-6FBF4CF1F15E}"/>
+              </a:ext>
+            </a:extLst>
+          </p:cNvPr>
+          <p:cNvSpPr txBox="1"/>
+          <p:nvPr/>
+        </p:nvSpPr>
+        <p:spPr>
+          <a:xfrm>
+            <a:off x="9264239" y="2370045"/>
+            <a:ext cx="922047" cy="253916"/>
+          </a:xfrm>
+          <a:prstGeom prst="rect">
+            <a:avLst/>
+          </a:prstGeom>
+          <a:noFill/>
+        </p:spPr>
+        <p:txBody>
+          <a:bodyPr wrap="none" rtlCol="0">
+            <a:spAutoFit/>
+          </a:bodyPr>
+          <a:lstStyle/>
+          <a:p>
+            <a:r>
+              <a:rPr lang="en-GB" sz="1050">
+                <a:latin typeface="Consolas" panose="020B0609020204030204" pitchFamily="49" charset="0"/>
+              </a:rPr>
+              <a:t>0x2000FFF4</a:t>
+            </a:r>
+            <a:endParaRPr lang="LID4096" sz="1050">
+              <a:latin typeface="Consolas" panose="020B0609020204030204" pitchFamily="49" charset="0"/>
+            </a:endParaRPr>
+          </a:p>
+        </p:txBody>
+      </p:sp>
+      <p:sp>
+        <p:nvSpPr>
+          <p:cNvPr id="51" name="TextBox 50">
+            <a:extLst>
+              <a:ext uri="{FF2B5EF4-FFF2-40B4-BE49-F238E27FC236}">
+                <a16:creationId xmlns:a16="http://schemas.microsoft.com/office/drawing/2014/main" id="{14FFD047-EAFD-3988-AB11-EBA55B5A49B5}"/>
+              </a:ext>
+            </a:extLst>
+          </p:cNvPr>
+          <p:cNvSpPr txBox="1"/>
+          <p:nvPr/>
+        </p:nvSpPr>
+        <p:spPr>
+          <a:xfrm>
+            <a:off x="9264239" y="979756"/>
+            <a:ext cx="1290738" cy="492443"/>
+          </a:xfrm>
+          <a:prstGeom prst="rect">
+            <a:avLst/>
+          </a:prstGeom>
+          <a:noFill/>
+        </p:spPr>
+        <p:txBody>
+          <a:bodyPr wrap="none" rtlCol="0">
+            <a:spAutoFit/>
+          </a:bodyPr>
+          <a:lstStyle/>
+          <a:p>
+            <a:r>
+              <a:rPr lang="en-GB" sz="1050" b="1">
+                <a:latin typeface="Consolas" panose="020B0609020204030204" pitchFamily="49" charset="0"/>
+              </a:rPr>
+              <a:t>sp</a:t>
+            </a:r>
+            <a:r>
+              <a:rPr lang="en-GB" sz="1050">
+                <a:latin typeface="Consolas" panose="020B0609020204030204" pitchFamily="49" charset="0"/>
+              </a:rPr>
+              <a:t> = 0x2000FFF4</a:t>
+            </a:r>
+          </a:p>
+          <a:p>
+            <a:pPr algn="ctr"/>
+            <a:r>
+              <a:rPr lang="en-GB" sz="500">
+                <a:latin typeface="Consolas" panose="020B0609020204030204" pitchFamily="49" charset="0"/>
+              </a:rPr>
+              <a:t>= &lt;top of stack&gt;</a:t>
+            </a:r>
+          </a:p>
+          <a:p>
+            <a:endParaRPr lang="LID4096" sz="1050">
+              <a:latin typeface="Consolas" panose="020B0609020204030204" pitchFamily="49" charset="0"/>
+            </a:endParaRPr>
+          </a:p>
+        </p:txBody>
+      </p:sp>
+      <p:sp>
+        <p:nvSpPr>
+          <p:cNvPr id="52" name="Arrow: Bent 51">
+            <a:extLst>
+              <a:ext uri="{FF2B5EF4-FFF2-40B4-BE49-F238E27FC236}">
+                <a16:creationId xmlns:a16="http://schemas.microsoft.com/office/drawing/2014/main" id="{1688CFAE-E67A-BD76-8446-853308A3CCD5}"/>
+              </a:ext>
+            </a:extLst>
+          </p:cNvPr>
+          <p:cNvSpPr/>
+          <p:nvPr/>
+        </p:nvSpPr>
+        <p:spPr>
+          <a:xfrm flipH="1" flipV="1">
+            <a:off x="10153588" y="1267486"/>
+            <a:ext cx="304800" cy="1286641"/>
+          </a:xfrm>
+          <a:prstGeom prst="bentArrow">
+            <a:avLst/>
+          </a:prstGeom>
+          <a:solidFill>
+            <a:schemeClr val="bg1">
+              <a:lumMod val="85000"/>
+            </a:schemeClr>
+          </a:solidFill>
+          <a:ln w="12700">
+            <a:solidFill>
+              <a:schemeClr val="tx1"/>
+            </a:solidFill>
+          </a:ln>
+        </p:spPr>
+        <p:style>
+          <a:lnRef idx="2">
+            <a:schemeClr val="accent1">
+              <a:shade val="15000"/>
+            </a:schemeClr>
+          </a:lnRef>
+          <a:fillRef idx="1">
+            <a:schemeClr val="accent1"/>
+          </a:fillRef>
+          <a:effectRef idx="0">
+            <a:schemeClr val="accent1"/>
+          </a:effectRef>
+          <a:fontRef idx="minor">
+            <a:schemeClr val="lt1"/>
+          </a:fontRef>
+        </p:style>
+        <p:txBody>
+          <a:bodyPr rtlCol="0" anchor="ctr"/>
+          <a:lstStyle/>
+          <a:p>
+            <a:pPr algn="ctr"/>
+            <a:endParaRPr lang="LID4096">
+              <a:solidFill>
+                <a:schemeClr val="tx1"/>
+              </a:solidFill>
+            </a:endParaRPr>
+          </a:p>
+        </p:txBody>
+      </p:sp>
+      <p:sp>
+        <p:nvSpPr>
+          <p:cNvPr id="53" name="TextBox 52">
+            <a:extLst>
+              <a:ext uri="{FF2B5EF4-FFF2-40B4-BE49-F238E27FC236}">
+                <a16:creationId xmlns:a16="http://schemas.microsoft.com/office/drawing/2014/main" id="{E371F57B-B1D4-F697-17FF-37C90A9C2C31}"/>
+              </a:ext>
+            </a:extLst>
+          </p:cNvPr>
+          <p:cNvSpPr txBox="1"/>
+          <p:nvPr/>
+        </p:nvSpPr>
+        <p:spPr>
+          <a:xfrm>
+            <a:off x="8517237" y="2360219"/>
+            <a:ext cx="338554" cy="261610"/>
+          </a:xfrm>
+          <a:prstGeom prst="rect">
+            <a:avLst/>
+          </a:prstGeom>
+          <a:noFill/>
+        </p:spPr>
+        <p:txBody>
+          <a:bodyPr wrap="none" rtlCol="0">
+            <a:spAutoFit/>
+          </a:bodyPr>
+          <a:lstStyle/>
+          <a:p>
+            <a:r>
+              <a:rPr lang="en-GB" sz="1100">
+                <a:latin typeface="Consolas" panose="020B0609020204030204" pitchFamily="49" charset="0"/>
+              </a:rPr>
+              <a:t>t2</a:t>
+            </a:r>
+            <a:endParaRPr lang="LID4096" sz="1100">
+              <a:latin typeface="Consolas" panose="020B0609020204030204" pitchFamily="49" charset="0"/>
+            </a:endParaRPr>
+          </a:p>
+        </p:txBody>
+      </p:sp>
+      <p:sp>
+        <p:nvSpPr>
+          <p:cNvPr id="54" name="TextBox 53">
+            <a:extLst>
+              <a:ext uri="{FF2B5EF4-FFF2-40B4-BE49-F238E27FC236}">
+                <a16:creationId xmlns:a16="http://schemas.microsoft.com/office/drawing/2014/main" id="{E0DF6C16-1997-B019-6886-CA4047AC6B24}"/>
+              </a:ext>
+            </a:extLst>
+          </p:cNvPr>
+          <p:cNvSpPr txBox="1"/>
+          <p:nvPr/>
+        </p:nvSpPr>
+        <p:spPr>
+          <a:xfrm>
+            <a:off x="8517237" y="2139641"/>
+            <a:ext cx="338554" cy="261610"/>
+          </a:xfrm>
+          <a:prstGeom prst="rect">
+            <a:avLst/>
+          </a:prstGeom>
+          <a:noFill/>
+        </p:spPr>
+        <p:txBody>
+          <a:bodyPr wrap="none" rtlCol="0">
+            <a:spAutoFit/>
+          </a:bodyPr>
+          <a:lstStyle/>
+          <a:p>
+            <a:r>
+              <a:rPr lang="en-GB" sz="1100">
+                <a:latin typeface="Consolas" panose="020B0609020204030204" pitchFamily="49" charset="0"/>
+              </a:rPr>
+              <a:t>t1</a:t>
+            </a:r>
+            <a:endParaRPr lang="LID4096" sz="1100">
+              <a:latin typeface="Consolas" panose="020B0609020204030204" pitchFamily="49" charset="0"/>
+            </a:endParaRPr>
+          </a:p>
+        </p:txBody>
+      </p:sp>
+      <p:sp>
+        <p:nvSpPr>
+          <p:cNvPr id="55" name="TextBox 54">
+            <a:extLst>
+              <a:ext uri="{FF2B5EF4-FFF2-40B4-BE49-F238E27FC236}">
+                <a16:creationId xmlns:a16="http://schemas.microsoft.com/office/drawing/2014/main" id="{B0395900-7B18-E88E-675B-7B53900361B7}"/>
+              </a:ext>
+            </a:extLst>
+          </p:cNvPr>
+          <p:cNvSpPr txBox="1"/>
+          <p:nvPr/>
+        </p:nvSpPr>
+        <p:spPr>
+          <a:xfrm>
+            <a:off x="8517237" y="1919063"/>
+            <a:ext cx="338554" cy="261610"/>
+          </a:xfrm>
+          <a:prstGeom prst="rect">
+            <a:avLst/>
+          </a:prstGeom>
+          <a:noFill/>
+        </p:spPr>
+        <p:txBody>
+          <a:bodyPr wrap="none" rtlCol="0">
+            <a:spAutoFit/>
+          </a:bodyPr>
+          <a:lstStyle/>
+          <a:p>
+            <a:r>
+              <a:rPr lang="en-GB" sz="1100">
+                <a:latin typeface="Consolas" panose="020B0609020204030204" pitchFamily="49" charset="0"/>
+              </a:rPr>
+              <a:t>t0</a:t>
+            </a:r>
+            <a:endParaRPr lang="LID4096" sz="1100">
+              <a:latin typeface="Consolas" panose="020B0609020204030204" pitchFamily="49" charset="0"/>
+            </a:endParaRPr>
+          </a:p>
+        </p:txBody>
+      </p:sp>
+      <p:cxnSp>
+        <p:nvCxnSpPr>
+          <p:cNvPr id="57" name="Straight Connector 56">
+            <a:extLst>
+              <a:ext uri="{FF2B5EF4-FFF2-40B4-BE49-F238E27FC236}">
+                <a16:creationId xmlns:a16="http://schemas.microsoft.com/office/drawing/2014/main" id="{822D86C9-FCBF-540D-BEC6-556A0DEFB629}"/>
+              </a:ext>
+            </a:extLst>
+          </p:cNvPr>
+          <p:cNvCxnSpPr>
+            <a:cxnSpLocks/>
+          </p:cNvCxnSpPr>
+          <p:nvPr/>
+        </p:nvCxnSpPr>
+        <p:spPr>
+          <a:xfrm>
+            <a:off x="4668033" y="901874"/>
+            <a:ext cx="0" cy="2233808"/>
+          </a:xfrm>
+          <a:prstGeom prst="line">
+            <a:avLst/>
+          </a:prstGeom>
+          <a:ln>
+            <a:solidFill>
+              <a:schemeClr val="tx1"/>
+            </a:solidFill>
+            <a:prstDash val="lgDash"/>
+          </a:ln>
+        </p:spPr>
+        <p:style>
+          <a:lnRef idx="2">
+            <a:schemeClr val="accent1"/>
+          </a:lnRef>
+          <a:fillRef idx="0">
+            <a:schemeClr val="accent1"/>
+          </a:fillRef>
+          <a:effectRef idx="1">
+            <a:schemeClr val="accent1"/>
+          </a:effectRef>
+          <a:fontRef idx="minor">
+            <a:schemeClr val="tx1"/>
+          </a:fontRef>
+        </p:style>
+      </p:cxnSp>
+      <p:cxnSp>
+        <p:nvCxnSpPr>
+          <p:cNvPr id="60" name="Straight Connector 59">
+            <a:extLst>
+              <a:ext uri="{FF2B5EF4-FFF2-40B4-BE49-F238E27FC236}">
+                <a16:creationId xmlns:a16="http://schemas.microsoft.com/office/drawing/2014/main" id="{EE3C25E7-0786-51C2-0FCF-D2D2F2657951}"/>
+              </a:ext>
+            </a:extLst>
+          </p:cNvPr>
+          <p:cNvCxnSpPr>
+            <a:cxnSpLocks/>
+          </p:cNvCxnSpPr>
+          <p:nvPr/>
+        </p:nvCxnSpPr>
+        <p:spPr>
+          <a:xfrm>
+            <a:off x="7693068" y="901874"/>
+            <a:ext cx="0" cy="2233808"/>
+          </a:xfrm>
+          <a:prstGeom prst="line">
+            <a:avLst/>
+          </a:prstGeom>
+          <a:ln>
+            <a:solidFill>
+              <a:schemeClr val="tx1"/>
+            </a:solidFill>
+            <a:prstDash val="lgDash"/>
+          </a:ln>
+        </p:spPr>
+        <p:style>
+          <a:lnRef idx="2">
+            <a:schemeClr val="accent1"/>
+          </a:lnRef>
+          <a:fillRef idx="0">
+            <a:schemeClr val="accent1"/>
+          </a:fillRef>
+          <a:effectRef idx="1">
+            <a:schemeClr val="accent1"/>
+          </a:effectRef>
+          <a:fontRef idx="minor">
+            <a:schemeClr val="tx1"/>
+          </a:fontRef>
+        </p:style>
+      </p:cxnSp>
+    </p:spTree>
+    <p:extLst>
+      <p:ext uri="{BB962C8B-B14F-4D97-AF65-F5344CB8AC3E}">
+        <p14:creationId xmlns:p14="http://schemas.microsoft.com/office/powerpoint/2010/main" val="297298827"/>
       </p:ext>
     </p:extLst>
   </p:cSld>

</xml_diff>

<commit_message>
Intro to GPIO mostly done.
</commit_message>
<xml_diff>
--- a/images/figures.pptx
+++ b/images/figures.pptx
@@ -204,7 +204,7 @@
           <a:p>
             <a:fld id="{1E717189-69EA-4142-945D-85EE3E06463B}" type="datetimeFigureOut">
               <a:rPr lang="LID4096" smtClean="0"/>
-              <a:t>09/30/2025</a:t>
+              <a:t>10/02/2025</a:t>
             </a:fld>
             <a:endParaRPr lang="LID4096"/>
           </a:p>
@@ -1368,7 +1368,7 @@
           <a:p>
             <a:fld id="{6E06BE13-2967-499D-85E1-E8100B951B63}" type="datetimeFigureOut">
               <a:rPr lang="LID4096" smtClean="0"/>
-              <a:t>09/30/2025</a:t>
+              <a:t>10/02/2025</a:t>
             </a:fld>
             <a:endParaRPr lang="LID4096"/>
           </a:p>
@@ -1568,7 +1568,7 @@
           <a:p>
             <a:fld id="{6E06BE13-2967-499D-85E1-E8100B951B63}" type="datetimeFigureOut">
               <a:rPr lang="LID4096" smtClean="0"/>
-              <a:t>09/30/2025</a:t>
+              <a:t>10/02/2025</a:t>
             </a:fld>
             <a:endParaRPr lang="LID4096"/>
           </a:p>
@@ -1778,7 +1778,7 @@
           <a:p>
             <a:fld id="{6E06BE13-2967-499D-85E1-E8100B951B63}" type="datetimeFigureOut">
               <a:rPr lang="LID4096" smtClean="0"/>
-              <a:t>09/30/2025</a:t>
+              <a:t>10/02/2025</a:t>
             </a:fld>
             <a:endParaRPr lang="LID4096"/>
           </a:p>
@@ -1978,7 +1978,7 @@
           <a:p>
             <a:fld id="{6E06BE13-2967-499D-85E1-E8100B951B63}" type="datetimeFigureOut">
               <a:rPr lang="LID4096" smtClean="0"/>
-              <a:t>09/30/2025</a:t>
+              <a:t>10/02/2025</a:t>
             </a:fld>
             <a:endParaRPr lang="LID4096"/>
           </a:p>
@@ -2254,7 +2254,7 @@
           <a:p>
             <a:fld id="{6E06BE13-2967-499D-85E1-E8100B951B63}" type="datetimeFigureOut">
               <a:rPr lang="LID4096" smtClean="0"/>
-              <a:t>09/30/2025</a:t>
+              <a:t>10/02/2025</a:t>
             </a:fld>
             <a:endParaRPr lang="LID4096"/>
           </a:p>
@@ -2522,7 +2522,7 @@
           <a:p>
             <a:fld id="{6E06BE13-2967-499D-85E1-E8100B951B63}" type="datetimeFigureOut">
               <a:rPr lang="LID4096" smtClean="0"/>
-              <a:t>09/30/2025</a:t>
+              <a:t>10/02/2025</a:t>
             </a:fld>
             <a:endParaRPr lang="LID4096"/>
           </a:p>
@@ -2937,7 +2937,7 @@
           <a:p>
             <a:fld id="{6E06BE13-2967-499D-85E1-E8100B951B63}" type="datetimeFigureOut">
               <a:rPr lang="LID4096" smtClean="0"/>
-              <a:t>09/30/2025</a:t>
+              <a:t>10/02/2025</a:t>
             </a:fld>
             <a:endParaRPr lang="LID4096"/>
           </a:p>
@@ -3079,7 +3079,7 @@
           <a:p>
             <a:fld id="{6E06BE13-2967-499D-85E1-E8100B951B63}" type="datetimeFigureOut">
               <a:rPr lang="LID4096" smtClean="0"/>
-              <a:t>09/30/2025</a:t>
+              <a:t>10/02/2025</a:t>
             </a:fld>
             <a:endParaRPr lang="LID4096"/>
           </a:p>
@@ -3192,7 +3192,7 @@
           <a:p>
             <a:fld id="{6E06BE13-2967-499D-85E1-E8100B951B63}" type="datetimeFigureOut">
               <a:rPr lang="LID4096" smtClean="0"/>
-              <a:t>09/30/2025</a:t>
+              <a:t>10/02/2025</a:t>
             </a:fld>
             <a:endParaRPr lang="LID4096"/>
           </a:p>
@@ -3505,7 +3505,7 @@
           <a:p>
             <a:fld id="{6E06BE13-2967-499D-85E1-E8100B951B63}" type="datetimeFigureOut">
               <a:rPr lang="LID4096" smtClean="0"/>
-              <a:t>09/30/2025</a:t>
+              <a:t>10/02/2025</a:t>
             </a:fld>
             <a:endParaRPr lang="LID4096"/>
           </a:p>
@@ -3794,7 +3794,7 @@
           <a:p>
             <a:fld id="{6E06BE13-2967-499D-85E1-E8100B951B63}" type="datetimeFigureOut">
               <a:rPr lang="LID4096" smtClean="0"/>
-              <a:t>09/30/2025</a:t>
+              <a:t>10/02/2025</a:t>
             </a:fld>
             <a:endParaRPr lang="LID4096"/>
           </a:p>
@@ -4037,7 +4037,7 @@
           <a:p>
             <a:fld id="{6E06BE13-2967-499D-85E1-E8100B951B63}" type="datetimeFigureOut">
               <a:rPr lang="LID4096" smtClean="0"/>
-              <a:t>09/30/2025</a:t>
+              <a:t>10/02/2025</a:t>
             </a:fld>
             <a:endParaRPr lang="LID4096"/>
           </a:p>
@@ -19722,41 +19722,6 @@
           </a:prstGeom>
         </p:spPr>
       </p:pic>
-      <p:pic>
-        <p:nvPicPr>
-          <p:cNvPr id="5" name="Picture 4">
-            <a:extLst>
-              <a:ext uri="{FF2B5EF4-FFF2-40B4-BE49-F238E27FC236}">
-                <a16:creationId xmlns:a16="http://schemas.microsoft.com/office/drawing/2014/main" id="{5054D953-0B4D-75FC-68B1-B570C8467F16}"/>
-              </a:ext>
-            </a:extLst>
-          </p:cNvPr>
-          <p:cNvPicPr>
-            <a:picLocks noChangeAspect="1"/>
-          </p:cNvPicPr>
-          <p:nvPr/>
-        </p:nvPicPr>
-        <p:blipFill>
-          <a:blip r:embed="rId5"/>
-          <a:stretch>
-            <a:fillRect/>
-          </a:stretch>
-        </p:blipFill>
-        <p:spPr>
-          <a:xfrm rot="10800000">
-            <a:off x="7532914" y="2381387"/>
-            <a:ext cx="2583575" cy="2493188"/>
-          </a:xfrm>
-          <a:prstGeom prst="rect">
-            <a:avLst/>
-          </a:prstGeom>
-          <a:ln w="50800">
-            <a:solidFill>
-              <a:schemeClr val="tx1"/>
-            </a:solidFill>
-          </a:ln>
-        </p:spPr>
-      </p:pic>
       <p:sp>
         <p:nvSpPr>
           <p:cNvPr id="6" name="Rectangle 5">
@@ -20580,6 +20545,446 @@
             <a:solidFill>
               <a:schemeClr val="bg1"/>
             </a:solidFill>
+          </a:ln>
+        </p:spPr>
+        <p:style>
+          <a:lnRef idx="2">
+            <a:schemeClr val="accent1">
+              <a:shade val="15000"/>
+            </a:schemeClr>
+          </a:lnRef>
+          <a:fillRef idx="1">
+            <a:schemeClr val="accent1"/>
+          </a:fillRef>
+          <a:effectRef idx="0">
+            <a:schemeClr val="accent1"/>
+          </a:effectRef>
+          <a:fontRef idx="minor">
+            <a:schemeClr val="lt1"/>
+          </a:fontRef>
+        </p:style>
+        <p:txBody>
+          <a:bodyPr rtlCol="0" anchor="ctr"/>
+          <a:lstStyle/>
+          <a:p>
+            <a:pPr algn="ctr"/>
+            <a:endParaRPr lang="LID4096"/>
+          </a:p>
+        </p:txBody>
+      </p:sp>
+      <p:grpSp>
+        <p:nvGrpSpPr>
+          <p:cNvPr id="2" name="Group 1">
+            <a:extLst>
+              <a:ext uri="{FF2B5EF4-FFF2-40B4-BE49-F238E27FC236}">
+                <a16:creationId xmlns:a16="http://schemas.microsoft.com/office/drawing/2014/main" id="{F2C7B1E9-3E94-BF4E-61FC-20FFE095A186}"/>
+              </a:ext>
+            </a:extLst>
+          </p:cNvPr>
+          <p:cNvGrpSpPr/>
+          <p:nvPr/>
+        </p:nvGrpSpPr>
+        <p:grpSpPr>
+          <a:xfrm>
+            <a:off x="7521273" y="2392378"/>
+            <a:ext cx="2583575" cy="2493188"/>
+            <a:chOff x="1099221" y="2243241"/>
+            <a:chExt cx="2583575" cy="2493188"/>
+          </a:xfrm>
+        </p:grpSpPr>
+        <p:pic>
+          <p:nvPicPr>
+            <p:cNvPr id="4" name="Picture 3">
+              <a:extLst>
+                <a:ext uri="{FF2B5EF4-FFF2-40B4-BE49-F238E27FC236}">
+                  <a16:creationId xmlns:a16="http://schemas.microsoft.com/office/drawing/2014/main" id="{F062227D-2F66-19C1-9222-F248E650A9CF}"/>
+                </a:ext>
+              </a:extLst>
+            </p:cNvPr>
+            <p:cNvPicPr>
+              <a:picLocks noChangeAspect="1"/>
+            </p:cNvPicPr>
+            <p:nvPr/>
+          </p:nvPicPr>
+          <p:blipFill>
+            <a:blip r:embed="rId5"/>
+            <a:stretch>
+              <a:fillRect/>
+            </a:stretch>
+          </p:blipFill>
+          <p:spPr>
+            <a:xfrm rot="10800000">
+              <a:off x="1099221" y="2243241"/>
+              <a:ext cx="2583575" cy="2493188"/>
+            </a:xfrm>
+            <a:prstGeom prst="rect">
+              <a:avLst/>
+            </a:prstGeom>
+            <a:ln w="50800">
+              <a:solidFill>
+                <a:schemeClr val="tx1"/>
+              </a:solidFill>
+            </a:ln>
+          </p:spPr>
+        </p:pic>
+        <p:sp>
+          <p:nvSpPr>
+            <p:cNvPr id="7" name="TextBox 6">
+              <a:extLst>
+                <a:ext uri="{FF2B5EF4-FFF2-40B4-BE49-F238E27FC236}">
+                  <a16:creationId xmlns:a16="http://schemas.microsoft.com/office/drawing/2014/main" id="{6C9121B9-A4C8-EE6A-B7E5-390B1C44798B}"/>
+                </a:ext>
+              </a:extLst>
+            </p:cNvPr>
+            <p:cNvSpPr txBox="1"/>
+            <p:nvPr/>
+          </p:nvSpPr>
+          <p:spPr>
+            <a:xfrm>
+              <a:off x="1545929" y="2644523"/>
+              <a:ext cx="947292" cy="738664"/>
+            </a:xfrm>
+            <a:prstGeom prst="rect">
+              <a:avLst/>
+            </a:prstGeom>
+            <a:solidFill>
+              <a:schemeClr val="accent2">
+                <a:lumMod val="40000"/>
+                <a:lumOff val="60000"/>
+              </a:schemeClr>
+            </a:solidFill>
+            <a:ln>
+              <a:solidFill>
+                <a:schemeClr val="accent2">
+                  <a:lumMod val="75000"/>
+                </a:schemeClr>
+              </a:solidFill>
+            </a:ln>
+          </p:spPr>
+          <p:txBody>
+            <a:bodyPr wrap="square" rtlCol="0">
+              <a:spAutoFit/>
+            </a:bodyPr>
+            <a:lstStyle/>
+            <a:p>
+              <a:pPr algn="ctr"/>
+              <a:r>
+                <a:rPr lang="en-US" sz="1000" dirty="0" err="1"/>
+                <a:t>Qingke</a:t>
+              </a:r>
+              <a:r>
+                <a:rPr lang="en-US" sz="1000" dirty="0"/>
+                <a:t> V4</a:t>
+              </a:r>
+            </a:p>
+            <a:p>
+              <a:pPr algn="ctr"/>
+              <a:r>
+                <a:rPr lang="en-US" sz="1000" dirty="0"/>
+                <a:t>RISCV</a:t>
+              </a:r>
+              <a:r>
+                <a:rPr lang="en-US" sz="1600" dirty="0"/>
+                <a:t> CPU</a:t>
+              </a:r>
+              <a:endParaRPr lang="LID4096" sz="1600" dirty="0"/>
+            </a:p>
+          </p:txBody>
+        </p:sp>
+        <p:sp>
+          <p:nvSpPr>
+            <p:cNvPr id="10" name="TextBox 9">
+              <a:extLst>
+                <a:ext uri="{FF2B5EF4-FFF2-40B4-BE49-F238E27FC236}">
+                  <a16:creationId xmlns:a16="http://schemas.microsoft.com/office/drawing/2014/main" id="{DCDFD54B-A8A3-E82A-E8E4-7FDF9C94A3DC}"/>
+                </a:ext>
+              </a:extLst>
+            </p:cNvPr>
+            <p:cNvSpPr txBox="1"/>
+            <p:nvPr/>
+          </p:nvSpPr>
+          <p:spPr>
+            <a:xfrm rot="16200000">
+              <a:off x="2553523" y="3289780"/>
+              <a:ext cx="947292" cy="400110"/>
+            </a:xfrm>
+            <a:prstGeom prst="rect">
+              <a:avLst/>
+            </a:prstGeom>
+            <a:solidFill>
+              <a:schemeClr val="tx2">
+                <a:lumMod val="25000"/>
+                <a:lumOff val="75000"/>
+              </a:schemeClr>
+            </a:solidFill>
+            <a:ln>
+              <a:solidFill>
+                <a:schemeClr val="tx2">
+                  <a:lumMod val="75000"/>
+                  <a:lumOff val="25000"/>
+                </a:schemeClr>
+              </a:solidFill>
+            </a:ln>
+          </p:spPr>
+          <p:txBody>
+            <a:bodyPr wrap="square" rtlCol="0">
+              <a:spAutoFit/>
+            </a:bodyPr>
+            <a:lstStyle/>
+            <a:p>
+              <a:pPr algn="ctr"/>
+              <a:r>
+                <a:rPr lang="en-US" sz="1000" dirty="0"/>
+                <a:t>Memory</a:t>
+              </a:r>
+              <a:br>
+                <a:rPr lang="en-US" sz="1000" dirty="0"/>
+              </a:br>
+              <a:r>
+                <a:rPr lang="en-US" sz="1000" dirty="0"/>
+                <a:t>Subsystem</a:t>
+              </a:r>
+            </a:p>
+          </p:txBody>
+        </p:sp>
+        <p:sp>
+          <p:nvSpPr>
+            <p:cNvPr id="12" name="Arrow: Up-Down 11">
+              <a:extLst>
+                <a:ext uri="{FF2B5EF4-FFF2-40B4-BE49-F238E27FC236}">
+                  <a16:creationId xmlns:a16="http://schemas.microsoft.com/office/drawing/2014/main" id="{CF52C8D5-523D-38D7-0FE1-8C0CCCA5EDA7}"/>
+                </a:ext>
+              </a:extLst>
+            </p:cNvPr>
+            <p:cNvSpPr/>
+            <p:nvPr/>
+          </p:nvSpPr>
+          <p:spPr>
+            <a:xfrm rot="18008206">
+              <a:off x="2548333" y="2960390"/>
+              <a:ext cx="223666" cy="434175"/>
+            </a:xfrm>
+            <a:prstGeom prst="upDownArrow">
+              <a:avLst/>
+            </a:prstGeom>
+            <a:solidFill>
+              <a:schemeClr val="bg1"/>
+            </a:solidFill>
+            <a:ln>
+              <a:solidFill>
+                <a:schemeClr val="bg1">
+                  <a:lumMod val="65000"/>
+                </a:schemeClr>
+              </a:solidFill>
+            </a:ln>
+          </p:spPr>
+          <p:style>
+            <a:lnRef idx="2">
+              <a:schemeClr val="accent1">
+                <a:shade val="15000"/>
+              </a:schemeClr>
+            </a:lnRef>
+            <a:fillRef idx="1">
+              <a:schemeClr val="accent1"/>
+            </a:fillRef>
+            <a:effectRef idx="0">
+              <a:schemeClr val="accent1"/>
+            </a:effectRef>
+            <a:fontRef idx="minor">
+              <a:schemeClr val="lt1"/>
+            </a:fontRef>
+          </p:style>
+          <p:txBody>
+            <a:bodyPr rtlCol="0" anchor="ctr"/>
+            <a:lstStyle/>
+            <a:p>
+              <a:pPr algn="ctr"/>
+              <a:endParaRPr lang="LID4096"/>
+            </a:p>
+          </p:txBody>
+        </p:sp>
+        <p:sp>
+          <p:nvSpPr>
+            <p:cNvPr id="18" name="Arrow: Up-Down 17">
+              <a:extLst>
+                <a:ext uri="{FF2B5EF4-FFF2-40B4-BE49-F238E27FC236}">
+                  <a16:creationId xmlns:a16="http://schemas.microsoft.com/office/drawing/2014/main" id="{B553BD9C-05B7-1499-9684-1335EDEFD846}"/>
+                </a:ext>
+              </a:extLst>
+            </p:cNvPr>
+            <p:cNvSpPr/>
+            <p:nvPr/>
+          </p:nvSpPr>
+          <p:spPr>
+            <a:xfrm rot="3255855">
+              <a:off x="2545972" y="3635006"/>
+              <a:ext cx="223666" cy="434175"/>
+            </a:xfrm>
+            <a:prstGeom prst="upDownArrow">
+              <a:avLst/>
+            </a:prstGeom>
+            <a:solidFill>
+              <a:schemeClr val="bg1"/>
+            </a:solidFill>
+            <a:ln>
+              <a:solidFill>
+                <a:schemeClr val="bg1">
+                  <a:lumMod val="65000"/>
+                </a:schemeClr>
+              </a:solidFill>
+            </a:ln>
+          </p:spPr>
+          <p:style>
+            <a:lnRef idx="2">
+              <a:schemeClr val="accent1">
+                <a:shade val="15000"/>
+              </a:schemeClr>
+            </a:lnRef>
+            <a:fillRef idx="1">
+              <a:schemeClr val="accent1"/>
+            </a:fillRef>
+            <a:effectRef idx="0">
+              <a:schemeClr val="accent1"/>
+            </a:effectRef>
+            <a:fontRef idx="minor">
+              <a:schemeClr val="lt1"/>
+            </a:fontRef>
+          </p:style>
+          <p:txBody>
+            <a:bodyPr rtlCol="0" anchor="ctr"/>
+            <a:lstStyle/>
+            <a:p>
+              <a:pPr algn="ctr"/>
+              <a:endParaRPr lang="LID4096"/>
+            </a:p>
+          </p:txBody>
+        </p:sp>
+        <p:sp>
+          <p:nvSpPr>
+            <p:cNvPr id="11" name="TextBox 10">
+              <a:extLst>
+                <a:ext uri="{FF2B5EF4-FFF2-40B4-BE49-F238E27FC236}">
+                  <a16:creationId xmlns:a16="http://schemas.microsoft.com/office/drawing/2014/main" id="{9E450C54-8F81-CCFF-059C-FAEFF500FB6E}"/>
+                </a:ext>
+              </a:extLst>
+            </p:cNvPr>
+            <p:cNvSpPr txBox="1"/>
+            <p:nvPr/>
+          </p:nvSpPr>
+          <p:spPr>
+            <a:xfrm>
+              <a:off x="1820089" y="3869605"/>
+              <a:ext cx="673132" cy="400110"/>
+            </a:xfrm>
+            <a:prstGeom prst="rect">
+              <a:avLst/>
+            </a:prstGeom>
+            <a:solidFill>
+              <a:schemeClr val="accent6">
+                <a:lumMod val="40000"/>
+                <a:lumOff val="60000"/>
+              </a:schemeClr>
+            </a:solidFill>
+            <a:ln>
+              <a:solidFill>
+                <a:schemeClr val="accent6">
+                  <a:lumMod val="75000"/>
+                </a:schemeClr>
+              </a:solidFill>
+            </a:ln>
+          </p:spPr>
+          <p:txBody>
+            <a:bodyPr wrap="square" rtlCol="0">
+              <a:spAutoFit/>
+            </a:bodyPr>
+            <a:lstStyle/>
+            <a:p>
+              <a:pPr algn="ctr"/>
+              <a:r>
+                <a:rPr lang="en-US" sz="1000" dirty="0"/>
+                <a:t>GPIO</a:t>
+              </a:r>
+              <a:br>
+                <a:rPr lang="en-US" sz="1000" dirty="0"/>
+              </a:br>
+              <a:r>
+                <a:rPr lang="en-US" sz="1000" dirty="0"/>
+                <a:t>Module</a:t>
+              </a:r>
+              <a:endParaRPr lang="LID4096" sz="1600" dirty="0"/>
+            </a:p>
+          </p:txBody>
+        </p:sp>
+      </p:grpSp>
+      <p:sp>
+        <p:nvSpPr>
+          <p:cNvPr id="19" name="Freeform: Shape 18">
+            <a:extLst>
+              <a:ext uri="{FF2B5EF4-FFF2-40B4-BE49-F238E27FC236}">
+                <a16:creationId xmlns:a16="http://schemas.microsoft.com/office/drawing/2014/main" id="{73D1891B-5ACE-86CD-A6B3-255B9ADEE755}"/>
+              </a:ext>
+            </a:extLst>
+          </p:cNvPr>
+          <p:cNvSpPr/>
+          <p:nvPr/>
+        </p:nvSpPr>
+        <p:spPr>
+          <a:xfrm>
+            <a:off x="7550668" y="3924464"/>
+            <a:ext cx="733460" cy="302183"/>
+          </a:xfrm>
+          <a:custGeom>
+            <a:avLst/>
+            <a:gdLst>
+              <a:gd name="connsiteX0" fmla="*/ 710328 w 710328"/>
+              <a:gd name="connsiteY0" fmla="*/ 298259 h 302183"/>
+              <a:gd name="connsiteX1" fmla="*/ 482709 w 710328"/>
+              <a:gd name="connsiteY1" fmla="*/ 302183 h 302183"/>
+              <a:gd name="connsiteX2" fmla="*/ 470935 w 710328"/>
+              <a:gd name="connsiteY2" fmla="*/ 0 h 302183"/>
+              <a:gd name="connsiteX3" fmla="*/ 0 w 710328"/>
+              <a:gd name="connsiteY3" fmla="*/ 15697 h 302183"/>
+            </a:gdLst>
+            <a:ahLst/>
+            <a:cxnLst>
+              <a:cxn ang="0">
+                <a:pos x="connsiteX0" y="connsiteY0"/>
+              </a:cxn>
+              <a:cxn ang="0">
+                <a:pos x="connsiteX1" y="connsiteY1"/>
+              </a:cxn>
+              <a:cxn ang="0">
+                <a:pos x="connsiteX2" y="connsiteY2"/>
+              </a:cxn>
+              <a:cxn ang="0">
+                <a:pos x="connsiteX3" y="connsiteY3"/>
+              </a:cxn>
+            </a:cxnLst>
+            <a:rect l="l" t="t" r="r" b="b"/>
+            <a:pathLst>
+              <a:path w="710328" h="302183">
+                <a:moveTo>
+                  <a:pt x="710328" y="298259"/>
+                </a:moveTo>
+                <a:lnTo>
+                  <a:pt x="482709" y="302183"/>
+                </a:lnTo>
+                <a:lnTo>
+                  <a:pt x="470935" y="0"/>
+                </a:lnTo>
+                <a:lnTo>
+                  <a:pt x="0" y="15697"/>
+                </a:lnTo>
+              </a:path>
+            </a:pathLst>
+          </a:custGeom>
+          <a:noFill/>
+          <a:ln cap="rnd">
+            <a:solidFill>
+              <a:schemeClr val="bg1"/>
+            </a:solidFill>
+            <a:headEnd type="triangle"/>
+            <a:tailEnd type="triangle"/>
           </a:ln>
         </p:spPr>
         <p:style>
@@ -25399,329 +25804,350 @@
           <a:chExt cx="0" cy="0"/>
         </a:xfrm>
       </p:grpSpPr>
-      <p:pic>
-        <p:nvPicPr>
-          <p:cNvPr id="5" name="Picture 4">
-            <a:extLst>
-              <a:ext uri="{FF2B5EF4-FFF2-40B4-BE49-F238E27FC236}">
-                <a16:creationId xmlns:a16="http://schemas.microsoft.com/office/drawing/2014/main" id="{C5B50886-5F6D-0A55-9A75-A3AA5C0030F0}"/>
-              </a:ext>
-            </a:extLst>
-          </p:cNvPr>
-          <p:cNvPicPr>
-            <a:picLocks noChangeAspect="1"/>
-          </p:cNvPicPr>
-          <p:nvPr/>
-        </p:nvPicPr>
-        <p:blipFill>
-          <a:blip r:embed="rId3"/>
-          <a:stretch>
-            <a:fillRect/>
-          </a:stretch>
-        </p:blipFill>
-        <p:spPr>
-          <a:xfrm rot="10800000">
+      <p:grpSp>
+        <p:nvGrpSpPr>
+          <p:cNvPr id="3" name="Group 2">
+            <a:extLst>
+              <a:ext uri="{FF2B5EF4-FFF2-40B4-BE49-F238E27FC236}">
+                <a16:creationId xmlns:a16="http://schemas.microsoft.com/office/drawing/2014/main" id="{863D55BC-AA77-6B48-F4CB-7ECFB275F1F1}"/>
+              </a:ext>
+            </a:extLst>
+          </p:cNvPr>
+          <p:cNvGrpSpPr/>
+          <p:nvPr/>
+        </p:nvGrpSpPr>
+        <p:grpSpPr>
+          <a:xfrm>
             <a:off x="1099221" y="2243241"/>
             <a:ext cx="2583575" cy="2493188"/>
-          </a:xfrm>
-          <a:prstGeom prst="rect">
-            <a:avLst/>
-          </a:prstGeom>
-          <a:ln w="50800">
-            <a:solidFill>
-              <a:schemeClr val="tx1"/>
-            </a:solidFill>
-          </a:ln>
-        </p:spPr>
-      </p:pic>
-      <p:sp>
-        <p:nvSpPr>
-          <p:cNvPr id="2" name="TextBox 1">
-            <a:extLst>
-              <a:ext uri="{FF2B5EF4-FFF2-40B4-BE49-F238E27FC236}">
-                <a16:creationId xmlns:a16="http://schemas.microsoft.com/office/drawing/2014/main" id="{B554C09C-B921-DFF1-1038-E272F33354F6}"/>
-              </a:ext>
-            </a:extLst>
-          </p:cNvPr>
-          <p:cNvSpPr txBox="1"/>
-          <p:nvPr/>
-        </p:nvSpPr>
-        <p:spPr>
-          <a:xfrm>
-            <a:off x="1545929" y="2644523"/>
-            <a:ext cx="947292" cy="738664"/>
-          </a:xfrm>
-          <a:prstGeom prst="rect">
-            <a:avLst/>
-          </a:prstGeom>
-          <a:solidFill>
-            <a:schemeClr val="accent2">
-              <a:lumMod val="40000"/>
-              <a:lumOff val="60000"/>
-            </a:schemeClr>
-          </a:solidFill>
-          <a:ln>
+            <a:chOff x="1099221" y="2243241"/>
+            <a:chExt cx="2583575" cy="2493188"/>
+          </a:xfrm>
+        </p:grpSpPr>
+        <p:pic>
+          <p:nvPicPr>
+            <p:cNvPr id="5" name="Picture 4">
+              <a:extLst>
+                <a:ext uri="{FF2B5EF4-FFF2-40B4-BE49-F238E27FC236}">
+                  <a16:creationId xmlns:a16="http://schemas.microsoft.com/office/drawing/2014/main" id="{C5B50886-5F6D-0A55-9A75-A3AA5C0030F0}"/>
+                </a:ext>
+              </a:extLst>
+            </p:cNvPr>
+            <p:cNvPicPr>
+              <a:picLocks noChangeAspect="1"/>
+            </p:cNvPicPr>
+            <p:nvPr/>
+          </p:nvPicPr>
+          <p:blipFill>
+            <a:blip r:embed="rId3"/>
+            <a:stretch>
+              <a:fillRect/>
+            </a:stretch>
+          </p:blipFill>
+          <p:spPr>
+            <a:xfrm rot="10800000">
+              <a:off x="1099221" y="2243241"/>
+              <a:ext cx="2583575" cy="2493188"/>
+            </a:xfrm>
+            <a:prstGeom prst="rect">
+              <a:avLst/>
+            </a:prstGeom>
+            <a:ln w="50800">
+              <a:solidFill>
+                <a:schemeClr val="tx1"/>
+              </a:solidFill>
+            </a:ln>
+          </p:spPr>
+        </p:pic>
+        <p:sp>
+          <p:nvSpPr>
+            <p:cNvPr id="2" name="TextBox 1">
+              <a:extLst>
+                <a:ext uri="{FF2B5EF4-FFF2-40B4-BE49-F238E27FC236}">
+                  <a16:creationId xmlns:a16="http://schemas.microsoft.com/office/drawing/2014/main" id="{B554C09C-B921-DFF1-1038-E272F33354F6}"/>
+                </a:ext>
+              </a:extLst>
+            </p:cNvPr>
+            <p:cNvSpPr txBox="1"/>
+            <p:nvPr/>
+          </p:nvSpPr>
+          <p:spPr>
+            <a:xfrm>
+              <a:off x="1545929" y="2644523"/>
+              <a:ext cx="947292" cy="738664"/>
+            </a:xfrm>
+            <a:prstGeom prst="rect">
+              <a:avLst/>
+            </a:prstGeom>
             <a:solidFill>
               <a:schemeClr val="accent2">
-                <a:lumMod val="75000"/>
-              </a:schemeClr>
-            </a:solidFill>
-          </a:ln>
-        </p:spPr>
-        <p:txBody>
-          <a:bodyPr wrap="square" rtlCol="0">
-            <a:spAutoFit/>
-          </a:bodyPr>
-          <a:lstStyle/>
-          <a:p>
-            <a:pPr algn="ctr"/>
-            <a:r>
-              <a:rPr lang="en-US" sz="1000" dirty="0" err="1"/>
-              <a:t>Qingke</a:t>
-            </a:r>
-            <a:r>
-              <a:rPr lang="en-US" sz="1000" dirty="0"/>
-              <a:t> V4</a:t>
-            </a:r>
-          </a:p>
-          <a:p>
-            <a:pPr algn="ctr"/>
-            <a:r>
-              <a:rPr lang="en-US" sz="1000" dirty="0"/>
-              <a:t>RISCV</a:t>
-            </a:r>
-            <a:r>
-              <a:rPr lang="en-US" sz="1600" dirty="0"/>
-              <a:t> CPU</a:t>
-            </a:r>
-            <a:endParaRPr lang="LID4096" sz="1600" dirty="0"/>
-          </a:p>
-        </p:txBody>
-      </p:sp>
-      <p:sp>
-        <p:nvSpPr>
-          <p:cNvPr id="4" name="TextBox 3">
-            <a:extLst>
-              <a:ext uri="{FF2B5EF4-FFF2-40B4-BE49-F238E27FC236}">
-                <a16:creationId xmlns:a16="http://schemas.microsoft.com/office/drawing/2014/main" id="{2DFFADC1-F978-F20E-1CA3-B901D7FAFFC7}"/>
-              </a:ext>
-            </a:extLst>
-          </p:cNvPr>
-          <p:cNvSpPr txBox="1"/>
-          <p:nvPr/>
-        </p:nvSpPr>
-        <p:spPr>
-          <a:xfrm rot="16200000">
-            <a:off x="2553523" y="3289780"/>
-            <a:ext cx="947292" cy="400110"/>
-          </a:xfrm>
-          <a:prstGeom prst="rect">
-            <a:avLst/>
-          </a:prstGeom>
-          <a:solidFill>
-            <a:schemeClr val="tx2">
-              <a:lumMod val="25000"/>
-              <a:lumOff val="75000"/>
-            </a:schemeClr>
-          </a:solidFill>
-          <a:ln>
+                <a:lumMod val="40000"/>
+                <a:lumOff val="60000"/>
+              </a:schemeClr>
+            </a:solidFill>
+            <a:ln>
+              <a:solidFill>
+                <a:schemeClr val="accent2">
+                  <a:lumMod val="75000"/>
+                </a:schemeClr>
+              </a:solidFill>
+            </a:ln>
+          </p:spPr>
+          <p:txBody>
+            <a:bodyPr wrap="square" rtlCol="0">
+              <a:spAutoFit/>
+            </a:bodyPr>
+            <a:lstStyle/>
+            <a:p>
+              <a:pPr algn="ctr"/>
+              <a:r>
+                <a:rPr lang="en-US" sz="1000" dirty="0" err="1"/>
+                <a:t>Qingke</a:t>
+              </a:r>
+              <a:r>
+                <a:rPr lang="en-US" sz="1000" dirty="0"/>
+                <a:t> V4</a:t>
+              </a:r>
+            </a:p>
+            <a:p>
+              <a:pPr algn="ctr"/>
+              <a:r>
+                <a:rPr lang="en-US" sz="1000" dirty="0"/>
+                <a:t>RISCV</a:t>
+              </a:r>
+              <a:r>
+                <a:rPr lang="en-US" sz="1600" dirty="0"/>
+                <a:t> CPU</a:t>
+              </a:r>
+              <a:endParaRPr lang="LID4096" sz="1600" dirty="0"/>
+            </a:p>
+          </p:txBody>
+        </p:sp>
+        <p:sp>
+          <p:nvSpPr>
+            <p:cNvPr id="4" name="TextBox 3">
+              <a:extLst>
+                <a:ext uri="{FF2B5EF4-FFF2-40B4-BE49-F238E27FC236}">
+                  <a16:creationId xmlns:a16="http://schemas.microsoft.com/office/drawing/2014/main" id="{2DFFADC1-F978-F20E-1CA3-B901D7FAFFC7}"/>
+                </a:ext>
+              </a:extLst>
+            </p:cNvPr>
+            <p:cNvSpPr txBox="1"/>
+            <p:nvPr/>
+          </p:nvSpPr>
+          <p:spPr>
+            <a:xfrm rot="16200000">
+              <a:off x="2553523" y="3289780"/>
+              <a:ext cx="947292" cy="400110"/>
+            </a:xfrm>
+            <a:prstGeom prst="rect">
+              <a:avLst/>
+            </a:prstGeom>
             <a:solidFill>
               <a:schemeClr val="tx2">
-                <a:lumMod val="75000"/>
-                <a:lumOff val="25000"/>
-              </a:schemeClr>
-            </a:solidFill>
-          </a:ln>
-        </p:spPr>
-        <p:txBody>
-          <a:bodyPr wrap="square" rtlCol="0">
-            <a:spAutoFit/>
-          </a:bodyPr>
-          <a:lstStyle/>
-          <a:p>
-            <a:pPr algn="ctr"/>
-            <a:r>
-              <a:rPr lang="en-US" sz="1000" dirty="0"/>
-              <a:t>Memory</a:t>
-            </a:r>
-            <a:br>
-              <a:rPr lang="en-US" sz="1000" dirty="0"/>
-            </a:br>
-            <a:r>
-              <a:rPr lang="en-US" sz="1000" dirty="0"/>
-              <a:t>Subsystem</a:t>
-            </a:r>
-          </a:p>
-        </p:txBody>
-      </p:sp>
-      <p:sp>
-        <p:nvSpPr>
-          <p:cNvPr id="7" name="TextBox 6">
-            <a:extLst>
-              <a:ext uri="{FF2B5EF4-FFF2-40B4-BE49-F238E27FC236}">
-                <a16:creationId xmlns:a16="http://schemas.microsoft.com/office/drawing/2014/main" id="{FABBAA12-17B8-03AE-D6FA-F35A36ED053C}"/>
-              </a:ext>
-            </a:extLst>
-          </p:cNvPr>
-          <p:cNvSpPr txBox="1"/>
-          <p:nvPr/>
-        </p:nvSpPr>
-        <p:spPr>
-          <a:xfrm>
-            <a:off x="1820089" y="3869605"/>
-            <a:ext cx="673132" cy="400110"/>
-          </a:xfrm>
-          <a:prstGeom prst="rect">
-            <a:avLst/>
-          </a:prstGeom>
-          <a:solidFill>
-            <a:schemeClr val="accent6">
-              <a:lumMod val="40000"/>
-              <a:lumOff val="60000"/>
-            </a:schemeClr>
-          </a:solidFill>
-          <a:ln>
+                <a:lumMod val="25000"/>
+                <a:lumOff val="75000"/>
+              </a:schemeClr>
+            </a:solidFill>
+            <a:ln>
+              <a:solidFill>
+                <a:schemeClr val="tx2">
+                  <a:lumMod val="75000"/>
+                  <a:lumOff val="25000"/>
+                </a:schemeClr>
+              </a:solidFill>
+            </a:ln>
+          </p:spPr>
+          <p:txBody>
+            <a:bodyPr wrap="square" rtlCol="0">
+              <a:spAutoFit/>
+            </a:bodyPr>
+            <a:lstStyle/>
+            <a:p>
+              <a:pPr algn="ctr"/>
+              <a:r>
+                <a:rPr lang="en-US" sz="1000" dirty="0"/>
+                <a:t>Memory</a:t>
+              </a:r>
+              <a:br>
+                <a:rPr lang="en-US" sz="1000" dirty="0"/>
+              </a:br>
+              <a:r>
+                <a:rPr lang="en-US" sz="1000" dirty="0"/>
+                <a:t>Subsystem</a:t>
+              </a:r>
+            </a:p>
+          </p:txBody>
+        </p:sp>
+        <p:sp>
+          <p:nvSpPr>
+            <p:cNvPr id="7" name="TextBox 6">
+              <a:extLst>
+                <a:ext uri="{FF2B5EF4-FFF2-40B4-BE49-F238E27FC236}">
+                  <a16:creationId xmlns:a16="http://schemas.microsoft.com/office/drawing/2014/main" id="{FABBAA12-17B8-03AE-D6FA-F35A36ED053C}"/>
+                </a:ext>
+              </a:extLst>
+            </p:cNvPr>
+            <p:cNvSpPr txBox="1"/>
+            <p:nvPr/>
+          </p:nvSpPr>
+          <p:spPr>
+            <a:xfrm>
+              <a:off x="1820089" y="3869605"/>
+              <a:ext cx="673132" cy="400110"/>
+            </a:xfrm>
+            <a:prstGeom prst="rect">
+              <a:avLst/>
+            </a:prstGeom>
             <a:solidFill>
               <a:schemeClr val="accent6">
-                <a:lumMod val="75000"/>
-              </a:schemeClr>
-            </a:solidFill>
-          </a:ln>
-        </p:spPr>
-        <p:txBody>
-          <a:bodyPr wrap="square" rtlCol="0">
-            <a:spAutoFit/>
-          </a:bodyPr>
-          <a:lstStyle/>
-          <a:p>
-            <a:pPr algn="ctr"/>
-            <a:r>
-              <a:rPr lang="en-US" sz="1000" dirty="0"/>
-              <a:t>GPIO</a:t>
-            </a:r>
-            <a:br>
-              <a:rPr lang="en-US" sz="1000" dirty="0"/>
-            </a:br>
-            <a:r>
-              <a:rPr lang="en-US" sz="1000" dirty="0"/>
-              <a:t>Module</a:t>
-            </a:r>
-            <a:endParaRPr lang="LID4096" sz="1600" dirty="0"/>
-          </a:p>
-        </p:txBody>
-      </p:sp>
-      <p:sp>
-        <p:nvSpPr>
-          <p:cNvPr id="11" name="Arrow: Up-Down 10">
-            <a:extLst>
-              <a:ext uri="{FF2B5EF4-FFF2-40B4-BE49-F238E27FC236}">
-                <a16:creationId xmlns:a16="http://schemas.microsoft.com/office/drawing/2014/main" id="{8BEC0DDB-83B1-319A-739C-AB857491BC06}"/>
-              </a:ext>
-            </a:extLst>
-          </p:cNvPr>
-          <p:cNvSpPr/>
-          <p:nvPr/>
-        </p:nvSpPr>
-        <p:spPr>
-          <a:xfrm rot="18008206">
-            <a:off x="2548333" y="2960390"/>
-            <a:ext cx="223666" cy="434175"/>
-          </a:xfrm>
-          <a:prstGeom prst="upDownArrow">
-            <a:avLst/>
-          </a:prstGeom>
-          <a:solidFill>
-            <a:schemeClr val="bg1"/>
-          </a:solidFill>
-          <a:ln>
-            <a:solidFill>
-              <a:schemeClr val="bg1">
-                <a:lumMod val="65000"/>
-              </a:schemeClr>
-            </a:solidFill>
-          </a:ln>
-        </p:spPr>
-        <p:style>
-          <a:lnRef idx="2">
-            <a:schemeClr val="accent1">
-              <a:shade val="15000"/>
-            </a:schemeClr>
-          </a:lnRef>
-          <a:fillRef idx="1">
-            <a:schemeClr val="accent1"/>
-          </a:fillRef>
-          <a:effectRef idx="0">
-            <a:schemeClr val="accent1"/>
-          </a:effectRef>
-          <a:fontRef idx="minor">
-            <a:schemeClr val="lt1"/>
-          </a:fontRef>
-        </p:style>
-        <p:txBody>
-          <a:bodyPr rtlCol="0" anchor="ctr"/>
-          <a:lstStyle/>
-          <a:p>
-            <a:pPr algn="ctr"/>
-            <a:endParaRPr lang="LID4096"/>
-          </a:p>
-        </p:txBody>
-      </p:sp>
-      <p:sp>
-        <p:nvSpPr>
-          <p:cNvPr id="12" name="Arrow: Up-Down 11">
-            <a:extLst>
-              <a:ext uri="{FF2B5EF4-FFF2-40B4-BE49-F238E27FC236}">
-                <a16:creationId xmlns:a16="http://schemas.microsoft.com/office/drawing/2014/main" id="{2F4DEB9A-5EDD-4CF8-563F-76DACFE7B238}"/>
-              </a:ext>
-            </a:extLst>
-          </p:cNvPr>
-          <p:cNvSpPr/>
-          <p:nvPr/>
-        </p:nvSpPr>
-        <p:spPr>
-          <a:xfrm rot="3255855">
-            <a:off x="2545972" y="3635006"/>
-            <a:ext cx="223666" cy="434175"/>
-          </a:xfrm>
-          <a:prstGeom prst="upDownArrow">
-            <a:avLst/>
-          </a:prstGeom>
-          <a:solidFill>
-            <a:schemeClr val="bg1"/>
-          </a:solidFill>
-          <a:ln>
-            <a:solidFill>
-              <a:schemeClr val="bg1">
-                <a:lumMod val="65000"/>
-              </a:schemeClr>
-            </a:solidFill>
-          </a:ln>
-        </p:spPr>
-        <p:style>
-          <a:lnRef idx="2">
-            <a:schemeClr val="accent1">
-              <a:shade val="15000"/>
-            </a:schemeClr>
-          </a:lnRef>
-          <a:fillRef idx="1">
-            <a:schemeClr val="accent1"/>
-          </a:fillRef>
-          <a:effectRef idx="0">
-            <a:schemeClr val="accent1"/>
-          </a:effectRef>
-          <a:fontRef idx="minor">
-            <a:schemeClr val="lt1"/>
-          </a:fontRef>
-        </p:style>
-        <p:txBody>
-          <a:bodyPr rtlCol="0" anchor="ctr"/>
-          <a:lstStyle/>
-          <a:p>
-            <a:pPr algn="ctr"/>
-            <a:endParaRPr lang="LID4096"/>
-          </a:p>
-        </p:txBody>
-      </p:sp>
+                <a:lumMod val="40000"/>
+                <a:lumOff val="60000"/>
+              </a:schemeClr>
+            </a:solidFill>
+            <a:ln>
+              <a:solidFill>
+                <a:schemeClr val="accent6">
+                  <a:lumMod val="75000"/>
+                </a:schemeClr>
+              </a:solidFill>
+            </a:ln>
+          </p:spPr>
+          <p:txBody>
+            <a:bodyPr wrap="square" rtlCol="0">
+              <a:spAutoFit/>
+            </a:bodyPr>
+            <a:lstStyle/>
+            <a:p>
+              <a:pPr algn="ctr"/>
+              <a:r>
+                <a:rPr lang="en-US" sz="1000" dirty="0"/>
+                <a:t>GPIO</a:t>
+              </a:r>
+              <a:br>
+                <a:rPr lang="en-US" sz="1000" dirty="0"/>
+              </a:br>
+              <a:r>
+                <a:rPr lang="en-US" sz="1000" dirty="0"/>
+                <a:t>Module</a:t>
+              </a:r>
+              <a:endParaRPr lang="LID4096" sz="1600" dirty="0"/>
+            </a:p>
+          </p:txBody>
+        </p:sp>
+        <p:sp>
+          <p:nvSpPr>
+            <p:cNvPr id="11" name="Arrow: Up-Down 10">
+              <a:extLst>
+                <a:ext uri="{FF2B5EF4-FFF2-40B4-BE49-F238E27FC236}">
+                  <a16:creationId xmlns:a16="http://schemas.microsoft.com/office/drawing/2014/main" id="{8BEC0DDB-83B1-319A-739C-AB857491BC06}"/>
+                </a:ext>
+              </a:extLst>
+            </p:cNvPr>
+            <p:cNvSpPr/>
+            <p:nvPr/>
+          </p:nvSpPr>
+          <p:spPr>
+            <a:xfrm rot="18008206">
+              <a:off x="2548333" y="2960390"/>
+              <a:ext cx="223666" cy="434175"/>
+            </a:xfrm>
+            <a:prstGeom prst="upDownArrow">
+              <a:avLst/>
+            </a:prstGeom>
+            <a:solidFill>
+              <a:schemeClr val="bg1"/>
+            </a:solidFill>
+            <a:ln>
+              <a:solidFill>
+                <a:schemeClr val="bg1">
+                  <a:lumMod val="65000"/>
+                </a:schemeClr>
+              </a:solidFill>
+            </a:ln>
+          </p:spPr>
+          <p:style>
+            <a:lnRef idx="2">
+              <a:schemeClr val="accent1">
+                <a:shade val="15000"/>
+              </a:schemeClr>
+            </a:lnRef>
+            <a:fillRef idx="1">
+              <a:schemeClr val="accent1"/>
+            </a:fillRef>
+            <a:effectRef idx="0">
+              <a:schemeClr val="accent1"/>
+            </a:effectRef>
+            <a:fontRef idx="minor">
+              <a:schemeClr val="lt1"/>
+            </a:fontRef>
+          </p:style>
+          <p:txBody>
+            <a:bodyPr rtlCol="0" anchor="ctr"/>
+            <a:lstStyle/>
+            <a:p>
+              <a:pPr algn="ctr"/>
+              <a:endParaRPr lang="LID4096"/>
+            </a:p>
+          </p:txBody>
+        </p:sp>
+        <p:sp>
+          <p:nvSpPr>
+            <p:cNvPr id="12" name="Arrow: Up-Down 11">
+              <a:extLst>
+                <a:ext uri="{FF2B5EF4-FFF2-40B4-BE49-F238E27FC236}">
+                  <a16:creationId xmlns:a16="http://schemas.microsoft.com/office/drawing/2014/main" id="{2F4DEB9A-5EDD-4CF8-563F-76DACFE7B238}"/>
+                </a:ext>
+              </a:extLst>
+            </p:cNvPr>
+            <p:cNvSpPr/>
+            <p:nvPr/>
+          </p:nvSpPr>
+          <p:spPr>
+            <a:xfrm rot="3255855">
+              <a:off x="2545972" y="3635006"/>
+              <a:ext cx="223666" cy="434175"/>
+            </a:xfrm>
+            <a:prstGeom prst="upDownArrow">
+              <a:avLst/>
+            </a:prstGeom>
+            <a:solidFill>
+              <a:schemeClr val="bg1"/>
+            </a:solidFill>
+            <a:ln>
+              <a:solidFill>
+                <a:schemeClr val="bg1">
+                  <a:lumMod val="65000"/>
+                </a:schemeClr>
+              </a:solidFill>
+            </a:ln>
+          </p:spPr>
+          <p:style>
+            <a:lnRef idx="2">
+              <a:schemeClr val="accent1">
+                <a:shade val="15000"/>
+              </a:schemeClr>
+            </a:lnRef>
+            <a:fillRef idx="1">
+              <a:schemeClr val="accent1"/>
+            </a:fillRef>
+            <a:effectRef idx="0">
+              <a:schemeClr val="accent1"/>
+            </a:effectRef>
+            <a:fontRef idx="minor">
+              <a:schemeClr val="lt1"/>
+            </a:fontRef>
+          </p:style>
+          <p:txBody>
+            <a:bodyPr rtlCol="0" anchor="ctr"/>
+            <a:lstStyle/>
+            <a:p>
+              <a:pPr algn="ctr"/>
+              <a:endParaRPr lang="LID4096"/>
+            </a:p>
+          </p:txBody>
+        </p:sp>
+      </p:grpSp>
       <p:pic>
         <p:nvPicPr>
           <p:cNvPr id="32" name="Picture 31">

</xml_diff>